<commit_message>
feat(trees): enhance binomial and Hull-White tree implementations with validation and tests
- Added validation checks for parameters in the BinomialTree and HullWhiteTree implementations to ensure they are finite and within acceptable ranges.
- Introduced new tests for the Tian tree to verify convergence to Black-Scholes pricing and adherence to put-call parity.
- Updated probability calculations in the Hull-White tree to improve boundary handling and ensure correct moment matching.
- Enhanced the ShortRateTree to measure calibration errors, improving the robustness of the calibration process.
- Refactored state management in tree frameworks to utilize defined state keys for better clarity and maintainability.

This update improves the reliability and accuracy of tree-based models in the valuation framework, ensuring better compliance with financial principles.
</commit_message>
<xml_diff>
--- a/finstack-py/examples/scripts/valuations/instruments/pik_coupon_pricing.pptx
+++ b/finstack-py/examples/scripts/valuations/instruments/pik_coupon_pricing.pptx
@@ -6085,7 +6085,7 @@
               </a:defRPr>
             </a:pPr>
             <a:r>
-              <a:t>Breakeven Z-Spreads: The Answer</a:t>
+              <a:t>Structural Model: Breakeven Z-Spreads</a:t>
             </a:r>
           </a:p>
         </p:txBody>
@@ -6121,7 +6121,7 @@
               </a:defRPr>
             </a:pPr>
             <a:r>
-              <a:t>Cash-equivalent Z-spreads by structure and credit quality</a:t>
+              <a:t>MC results using historical PDs for barrier calibration</a:t>
             </a:r>
           </a:p>
         </p:txBody>
@@ -7099,7 +7099,7 @@
               </a:defRPr>
             </a:pPr>
             <a:r>
-              <a:t>Z-spreads are cash-equivalent: the Z-spread on a standard cash-pay bond that reproduces each structure’s MC price.</a:t>
+              <a:t>Z-spreads are cash-equivalent.  MC barriers calibrated from historical PDs (BB+ = 0.2%/yr → ~2% 5Y default rate).</a:t>
             </a:r>
           </a:p>
         </p:txBody>
@@ -7138,7 +7138,7 @@
               </a:defRPr>
             </a:pPr>
             <a:r>
-              <a:t>BB+ to BB−: PIK Z-spread is BELOW cash — compounding benefit exceeds survival penalty when defaults are rare. The simple model (slide 6) predicted PIK always trades below cash — the structural model reverses this for strong credits</a:t>
+              <a:t>BB+ to BB−: the MC model shows PIK Z-spread below cash. Under historical default rates (1–5% over 5Y), PIK compounding survives on ~98% of paths — but recall this uses lower PDs than market spreads imply (slide 7)</a:t>
             </a:r>
           </a:p>
           <a:p>
@@ -7154,7 +7154,7 @@
               </a:defRPr>
             </a:pPr>
             <a:r>
-              <a:t>Crossover near B: the feedback loop starts to overcome the compounding benefit (ΔZ = +37bp)</a:t>
+              <a:t>Crossover near B: the feedback loop starts to dominate (ΔZ = +37bp). Both models agree PIK costs from here</a:t>
             </a:r>
           </a:p>
           <a:p>
@@ -7170,7 +7170,7 @@
               </a:defRPr>
             </a:pPr>
             <a:r>
-              <a:t>B− to CCC: PIK premium of +141bp to +262bp. Here both models agree PIK is cheaper, but the structural model captures the self-reinforcing spiral that the simple model missed</a:t>
+              <a:t>B− to CCC: PIK premium of +141bp to +262bp. The leverage spiral is unambiguous — this result is robust across calibration assumptions</a:t>
             </a:r>
           </a:p>
         </p:txBody>
@@ -7183,8 +7183,8 @@
         </p:nvSpPr>
         <p:spPr>
           <a:xfrm>
-            <a:off x="1371600" y="5943600"/>
-            <a:ext cx="6400800" cy="457200"/>
+            <a:off x="914400" y="5943600"/>
+            <a:ext cx="7315200" cy="457200"/>
           </a:xfrm>
           <a:prstGeom prst="roundRect">
             <a:avLst/>
@@ -7223,7 +7223,7 @@
               </a:defRPr>
             </a:pPr>
             <a:r>
-              <a:t>The PIK premium crosses zero near 300bp market spread. Below that, PIK actually benefits investors.</a:t>
+              <a:t>For weak credits (B and below): PIK premium is large and robust. For strong credits: the sign depends on whether you calibrate to market or historical defaults.</a:t>
             </a:r>
           </a:p>
         </p:txBody>
@@ -9372,7 +9372,7 @@
               </a:defRPr>
             </a:pPr>
             <a:r>
-              <a:t>PIK BENEFITS INVESTOR</a:t>
+              <a:t>LOW IMPACT ZONE</a:t>
             </a:r>
           </a:p>
         </p:txBody>
@@ -9412,7 +9412,7 @@
             </a:r>
             <a:br/>
             <a:r>
-              <a:t>PIK compounding dominates</a:t>
+              <a:t>Premium small, sign model-dep.</a:t>
             </a:r>
           </a:p>
         </p:txBody>
@@ -10946,7 +10946,7 @@
               </a:defRPr>
             </a:pPr>
             <a:r>
-              <a:t>Simple vs Structural: Why the Model Matters</a:t>
+              <a:t>Why the Models Disagree</a:t>
             </a:r>
           </a:p>
         </p:txBody>
@@ -10982,7 +10982,7 @@
               </a:defRPr>
             </a:pPr>
             <a:r>
-              <a:t>Hazard-rate model vs Merton MC across the credit spectrum</a:t>
+              <a:t>Calibration assumptions drive the answer for strong credits</a:t>
             </a:r>
           </a:p>
         </p:txBody>
@@ -11033,7 +11033,7 @@
         </p:nvGraphicFramePr>
         <p:xfrm>
           <a:off x="457200" y="1188720"/>
-          <a:ext cx="6675120" cy="1920239"/>
+          <a:ext cx="6949440" cy="1920239"/>
         </p:xfrm>
         <a:graphic>
           <a:graphicData uri="http://schemas.openxmlformats.org/drawingml/2006/table">
@@ -11042,12 +11042,11 @@
                 <a:tableStyleId>{5C22544A-7EE6-4342-B048-85BDC9FD1C3A}</a:tableStyleId>
               </a:tblPr>
               <a:tblGrid>
-                <a:gridCol w="1188720"/>
-                <a:gridCol w="914400"/>
-                <a:gridCol w="914400"/>
-                <a:gridCol w="914400"/>
-                <a:gridCol w="914400"/>
-                <a:gridCol w="914400"/>
+                <a:gridCol w="1828800"/>
+                <a:gridCol w="1005840"/>
+                <a:gridCol w="1005840"/>
+                <a:gridCol w="1097280"/>
+                <a:gridCol w="1097280"/>
                 <a:gridCol w="914400"/>
               </a:tblGrid>
               <a:tr h="320039">
@@ -11089,7 +11088,7 @@
                         </a:defRPr>
                       </a:pPr>
                       <a:r>
-                        <a:t>HR Cash</a:t>
+                        <a:t>HR ΔPrice</a:t>
                       </a:r>
                     </a:p>
                   </a:txBody>
@@ -11113,7 +11112,7 @@
                         </a:defRPr>
                       </a:pPr>
                       <a:r>
-                        <a:t>HR PIK</a:t>
+                        <a:t>MC ΔPrice</a:t>
                       </a:r>
                     </a:p>
                   </a:txBody>
@@ -11137,7 +11136,7 @@
                         </a:defRPr>
                       </a:pPr>
                       <a:r>
-                        <a:t>MC Cash</a:t>
+                        <a:t>HR 5Y PD</a:t>
                       </a:r>
                     </a:p>
                   </a:txBody>
@@ -11161,7 +11160,7 @@
                         </a:defRPr>
                       </a:pPr>
                       <a:r>
-                        <a:t>MC PIK</a:t>
+                        <a:t>MC DefRate</a:t>
                       </a:r>
                     </a:p>
                   </a:txBody>
@@ -11185,31 +11184,7 @@
                         </a:defRPr>
                       </a:pPr>
                       <a:r>
-                        <a:t>HR ΔZ</a:t>
-                      </a:r>
-                    </a:p>
-                  </a:txBody>
-                  <a:tcPr>
-                    <a:solidFill>
-                      <a:srgbClr val="2C3E6B"/>
-                    </a:solidFill>
-                  </a:tcPr>
-                </a:tc>
-                <a:tc>
-                  <a:txBody>
-                    <a:bodyPr/>
-                    <a:lstStyle/>
-                    <a:p>
-                      <a:pPr algn="ctr">
-                        <a:defRPr sz="1100" b="1">
-                          <a:solidFill>
-                            <a:srgbClr val="FFFFFF"/>
-                          </a:solidFill>
-                          <a:latin typeface="Calibri"/>
-                        </a:defRPr>
-                      </a:pPr>
-                      <a:r>
-                        <a:t>MC ΔZ</a:t>
+                        <a:t>Ratio</a:t>
                       </a:r>
                     </a:p>
                   </a:txBody>
@@ -11259,7 +11234,7 @@
                         </a:defRPr>
                       </a:pPr>
                       <a:r>
-                        <a:t>113.35</a:t>
+                        <a:t>−2.5</a:t>
                       </a:r>
                     </a:p>
                   </a:txBody>
@@ -11283,7 +11258,7 @@
                         </a:defRPr>
                       </a:pPr>
                       <a:r>
-                        <a:t>110.89</a:t>
+                        <a:t>+3.0</a:t>
                       </a:r>
                     </a:p>
                   </a:txBody>
@@ -11307,7 +11282,7 @@
                         </a:defRPr>
                       </a:pPr>
                       <a:r>
-                        <a:t>116.48</a:t>
+                        <a:t>6.9%</a:t>
                       </a:r>
                     </a:p>
                   </a:txBody>
@@ -11331,7 +11306,7 @@
                         </a:defRPr>
                       </a:pPr>
                       <a:r>
-                        <a:t>119.46</a:t>
+                        <a:t>1.9%</a:t>
                       </a:r>
                     </a:p>
                   </a:txBody>
@@ -11355,13 +11330,39 @@
                         </a:defRPr>
                       </a:pPr>
                       <a:r>
-                        <a:t>−2.5</a:t>
+                        <a:t>3.6×</a:t>
                       </a:r>
                     </a:p>
                   </a:txBody>
                   <a:tcPr>
                     <a:solidFill>
                       <a:srgbClr val="FFFFFF"/>
+                    </a:solidFill>
+                  </a:tcPr>
+                </a:tc>
+              </a:tr>
+              <a:tr h="320039">
+                <a:tc>
+                  <a:txBody>
+                    <a:bodyPr/>
+                    <a:lstStyle/>
+                    <a:p>
+                      <a:pPr algn="l">
+                        <a:defRPr sz="1100">
+                          <a:solidFill>
+                            <a:srgbClr val="2D2D3D"/>
+                          </a:solidFill>
+                          <a:latin typeface="Calibri"/>
+                        </a:defRPr>
+                      </a:pPr>
+                      <a:r>
+                        <a:t>BB−</a:t>
+                      </a:r>
+                    </a:p>
+                  </a:txBody>
+                  <a:tcPr>
+                    <a:solidFill>
+                      <a:srgbClr val="E8EBF5"/>
                     </a:solidFill>
                   </a:tcPr>
                 </a:tc>
@@ -11379,13 +11380,109 @@
                         </a:defRPr>
                       </a:pPr>
                       <a:r>
-                        <a:t>+3.0</a:t>
-                      </a:r>
-                    </a:p>
-                  </a:txBody>
-                  <a:tcPr>
-                    <a:solidFill>
-                      <a:srgbClr val="FFFFFF"/>
+                        <a:t>−3.8</a:t>
+                      </a:r>
+                    </a:p>
+                  </a:txBody>
+                  <a:tcPr>
+                    <a:solidFill>
+                      <a:srgbClr val="E8EBF5"/>
+                    </a:solidFill>
+                  </a:tcPr>
+                </a:tc>
+                <a:tc>
+                  <a:txBody>
+                    <a:bodyPr/>
+                    <a:lstStyle/>
+                    <a:p>
+                      <a:pPr algn="r">
+                        <a:defRPr sz="1100">
+                          <a:solidFill>
+                            <a:srgbClr val="2D2D3D"/>
+                          </a:solidFill>
+                          <a:latin typeface="Calibri"/>
+                        </a:defRPr>
+                      </a:pPr>
+                      <a:r>
+                        <a:t>+1.1</a:t>
+                      </a:r>
+                    </a:p>
+                  </a:txBody>
+                  <a:tcPr>
+                    <a:solidFill>
+                      <a:srgbClr val="E8EBF5"/>
+                    </a:solidFill>
+                  </a:tcPr>
+                </a:tc>
+                <a:tc>
+                  <a:txBody>
+                    <a:bodyPr/>
+                    <a:lstStyle/>
+                    <a:p>
+                      <a:pPr algn="r">
+                        <a:defRPr sz="1100">
+                          <a:solidFill>
+                            <a:srgbClr val="2D2D3D"/>
+                          </a:solidFill>
+                          <a:latin typeface="Calibri"/>
+                        </a:defRPr>
+                      </a:pPr>
+                      <a:r>
+                        <a:t>15.5%</a:t>
+                      </a:r>
+                    </a:p>
+                  </a:txBody>
+                  <a:tcPr>
+                    <a:solidFill>
+                      <a:srgbClr val="E8EBF5"/>
+                    </a:solidFill>
+                  </a:tcPr>
+                </a:tc>
+                <a:tc>
+                  <a:txBody>
+                    <a:bodyPr/>
+                    <a:lstStyle/>
+                    <a:p>
+                      <a:pPr algn="r">
+                        <a:defRPr sz="1100">
+                          <a:solidFill>
+                            <a:srgbClr val="2D2D3D"/>
+                          </a:solidFill>
+                          <a:latin typeface="Calibri"/>
+                        </a:defRPr>
+                      </a:pPr>
+                      <a:r>
+                        <a:t>5.8%</a:t>
+                      </a:r>
+                    </a:p>
+                  </a:txBody>
+                  <a:tcPr>
+                    <a:solidFill>
+                      <a:srgbClr val="E8EBF5"/>
+                    </a:solidFill>
+                  </a:tcPr>
+                </a:tc>
+                <a:tc>
+                  <a:txBody>
+                    <a:bodyPr/>
+                    <a:lstStyle/>
+                    <a:p>
+                      <a:pPr algn="r">
+                        <a:defRPr sz="1100">
+                          <a:solidFill>
+                            <a:srgbClr val="2D2D3D"/>
+                          </a:solidFill>
+                          <a:latin typeface="Calibri"/>
+                        </a:defRPr>
+                      </a:pPr>
+                      <a:r>
+                        <a:t>2.7×</a:t>
+                      </a:r>
+                    </a:p>
+                  </a:txBody>
+                  <a:tcPr>
+                    <a:solidFill>
+                      <a:srgbClr val="E8EBF5"/>
                     </a:solidFill>
                   </a:tcPr>
                 </a:tc>
@@ -11405,13 +11502,13 @@
                         </a:defRPr>
                       </a:pPr>
                       <a:r>
-                        <a:t>BB−</a:t>
-                      </a:r>
-                    </a:p>
-                  </a:txBody>
-                  <a:tcPr>
-                    <a:solidFill>
-                      <a:srgbClr val="E8EBF5"/>
+                        <a:t>B</a:t>
+                      </a:r>
+                    </a:p>
+                  </a:txBody>
+                  <a:tcPr>
+                    <a:solidFill>
+                      <a:srgbClr val="FFFFFF"/>
                     </a:solidFill>
                   </a:tcPr>
                 </a:tc>
@@ -11429,13 +11526,13 @@
                         </a:defRPr>
                       </a:pPr>
                       <a:r>
-                        <a:t>107.56</a:t>
-                      </a:r>
-                    </a:p>
-                  </a:txBody>
-                  <a:tcPr>
-                    <a:solidFill>
-                      <a:srgbClr val="E8EBF5"/>
+                        <a:t>−5.3</a:t>
+                      </a:r>
+                    </a:p>
+                  </a:txBody>
+                  <a:tcPr>
+                    <a:solidFill>
+                      <a:srgbClr val="FFFFFF"/>
                     </a:solidFill>
                   </a:tcPr>
                 </a:tc>
@@ -11453,13 +11550,13 @@
                         </a:defRPr>
                       </a:pPr>
                       <a:r>
-                        <a:t>103.76</a:t>
-                      </a:r>
-                    </a:p>
-                  </a:txBody>
-                  <a:tcPr>
-                    <a:solidFill>
-                      <a:srgbClr val="E8EBF5"/>
+                        <a:t>−1.6</a:t>
+                      </a:r>
+                    </a:p>
+                  </a:txBody>
+                  <a:tcPr>
+                    <a:solidFill>
+                      <a:srgbClr val="FFFFFF"/>
                     </a:solidFill>
                   </a:tcPr>
                 </a:tc>
@@ -11477,13 +11574,13 @@
                         </a:defRPr>
                       </a:pPr>
                       <a:r>
-                        <a:t>112.12</a:t>
-                      </a:r>
-                    </a:p>
-                  </a:txBody>
-                  <a:tcPr>
-                    <a:solidFill>
-                      <a:srgbClr val="E8EBF5"/>
+                        <a:t>25.6%</a:t>
+                      </a:r>
+                    </a:p>
+                  </a:txBody>
+                  <a:tcPr>
+                    <a:solidFill>
+                      <a:srgbClr val="FFFFFF"/>
                     </a:solidFill>
                   </a:tcPr>
                 </a:tc>
@@ -11501,13 +11598,13 @@
                         </a:defRPr>
                       </a:pPr>
                       <a:r>
-                        <a:t>113.17</a:t>
-                      </a:r>
-                    </a:p>
-                  </a:txBody>
-                  <a:tcPr>
-                    <a:solidFill>
-                      <a:srgbClr val="E8EBF5"/>
+                        <a:t>13.2%</a:t>
+                      </a:r>
+                    </a:p>
+                  </a:txBody>
+                  <a:tcPr>
+                    <a:solidFill>
+                      <a:srgbClr val="FFFFFF"/>
                     </a:solidFill>
                   </a:tcPr>
                 </a:tc>
@@ -11525,7 +11622,33 @@
                         </a:defRPr>
                       </a:pPr>
                       <a:r>
-                        <a:t>−3.8</a:t>
+                        <a:t>1.9×</a:t>
+                      </a:r>
+                    </a:p>
+                  </a:txBody>
+                  <a:tcPr>
+                    <a:solidFill>
+                      <a:srgbClr val="FFFFFF"/>
+                    </a:solidFill>
+                  </a:tcPr>
+                </a:tc>
+              </a:tr>
+              <a:tr h="320039">
+                <a:tc>
+                  <a:txBody>
+                    <a:bodyPr/>
+                    <a:lstStyle/>
+                    <a:p>
+                      <a:pPr algn="l">
+                        <a:defRPr sz="1100">
+                          <a:solidFill>
+                            <a:srgbClr val="2D2D3D"/>
+                          </a:solidFill>
+                          <a:latin typeface="Calibri"/>
+                        </a:defRPr>
+                      </a:pPr>
+                      <a:r>
+                        <a:t>B−</a:t>
                       </a:r>
                     </a:p>
                   </a:txBody>
@@ -11549,7 +11672,7 @@
                         </a:defRPr>
                       </a:pPr>
                       <a:r>
-                        <a:t>+1.1</a:t>
+                        <a:t>−6.9</a:t>
                       </a:r>
                     </a:p>
                   </a:txBody>
@@ -11559,8 +11682,104 @@
                     </a:solidFill>
                   </a:tcPr>
                 </a:tc>
+                <a:tc>
+                  <a:txBody>
+                    <a:bodyPr/>
+                    <a:lstStyle/>
+                    <a:p>
+                      <a:pPr algn="r">
+                        <a:defRPr sz="1100">
+                          <a:solidFill>
+                            <a:srgbClr val="2D2D3D"/>
+                          </a:solidFill>
+                          <a:latin typeface="Calibri"/>
+                        </a:defRPr>
+                      </a:pPr>
+                      <a:r>
+                        <a:t>−4.9</a:t>
+                      </a:r>
+                    </a:p>
+                  </a:txBody>
+                  <a:tcPr>
+                    <a:solidFill>
+                      <a:srgbClr val="E8EBF5"/>
+                    </a:solidFill>
+                  </a:tcPr>
+                </a:tc>
+                <a:tc>
+                  <a:txBody>
+                    <a:bodyPr/>
+                    <a:lstStyle/>
+                    <a:p>
+                      <a:pPr algn="r">
+                        <a:defRPr sz="1100">
+                          <a:solidFill>
+                            <a:srgbClr val="2D2D3D"/>
+                          </a:solidFill>
+                          <a:latin typeface="Calibri"/>
+                        </a:defRPr>
+                      </a:pPr>
+                      <a:r>
+                        <a:t>36.5%</a:t>
+                      </a:r>
+                    </a:p>
+                  </a:txBody>
+                  <a:tcPr>
+                    <a:solidFill>
+                      <a:srgbClr val="E8EBF5"/>
+                    </a:solidFill>
+                  </a:tcPr>
+                </a:tc>
+                <a:tc>
+                  <a:txBody>
+                    <a:bodyPr/>
+                    <a:lstStyle/>
+                    <a:p>
+                      <a:pPr algn="r">
+                        <a:defRPr sz="1100">
+                          <a:solidFill>
+                            <a:srgbClr val="2D2D3D"/>
+                          </a:solidFill>
+                          <a:latin typeface="Calibri"/>
+                        </a:defRPr>
+                      </a:pPr>
+                      <a:r>
+                        <a:t>25.7%</a:t>
+                      </a:r>
+                    </a:p>
+                  </a:txBody>
+                  <a:tcPr>
+                    <a:solidFill>
+                      <a:srgbClr val="E8EBF5"/>
+                    </a:solidFill>
+                  </a:tcPr>
+                </a:tc>
+                <a:tc>
+                  <a:txBody>
+                    <a:bodyPr/>
+                    <a:lstStyle/>
+                    <a:p>
+                      <a:pPr algn="r">
+                        <a:defRPr sz="1100">
+                          <a:solidFill>
+                            <a:srgbClr val="2D2D3D"/>
+                          </a:solidFill>
+                          <a:latin typeface="Calibri"/>
+                        </a:defRPr>
+                      </a:pPr>
+                      <a:r>
+                        <a:t>1.4×</a:t>
+                      </a:r>
+                    </a:p>
+                  </a:txBody>
+                  <a:tcPr>
+                    <a:solidFill>
+                      <a:srgbClr val="E8EBF5"/>
+                    </a:solidFill>
+                  </a:tcPr>
+                </a:tc>
               </a:tr>
-              <a:tr h="320039">
+              <a:tr h="320044">
                 <a:tc>
                   <a:txBody>
                     <a:bodyPr/>
@@ -11575,7 +11794,7 @@
                         </a:defRPr>
                       </a:pPr>
                       <a:r>
-                        <a:t>B</a:t>
+                        <a:t>CCC</a:t>
                       </a:r>
                     </a:p>
                   </a:txBody>
@@ -11599,7 +11818,7 @@
                         </a:defRPr>
                       </a:pPr>
                       <a:r>
-                        <a:t>99.76</a:t>
+                        <a:t>−8.8</a:t>
                       </a:r>
                     </a:p>
                   </a:txBody>
@@ -11623,7 +11842,7 @@
                         </a:defRPr>
                       </a:pPr>
                       <a:r>
-                        <a:t>94.44</a:t>
+                        <a:t>−6.2</a:t>
                       </a:r>
                     </a:p>
                   </a:txBody>
@@ -11647,7 +11866,7 @@
                         </a:defRPr>
                       </a:pPr>
                       <a:r>
-                        <a:t>103.87</a:t>
+                        <a:t>52.0%</a:t>
                       </a:r>
                     </a:p>
                   </a:txBody>
@@ -11671,7 +11890,7 @@
                         </a:defRPr>
                       </a:pPr>
                       <a:r>
-                        <a:t>102.26</a:t>
+                        <a:t>42.3%</a:t>
                       </a:r>
                     </a:p>
                   </a:txBody>
@@ -11695,371 +11914,7 @@
                         </a:defRPr>
                       </a:pPr>
                       <a:r>
-                        <a:t>−5.3</a:t>
-                      </a:r>
-                    </a:p>
-                  </a:txBody>
-                  <a:tcPr>
-                    <a:solidFill>
-                      <a:srgbClr val="FFFFFF"/>
-                    </a:solidFill>
-                  </a:tcPr>
-                </a:tc>
-                <a:tc>
-                  <a:txBody>
-                    <a:bodyPr/>
-                    <a:lstStyle/>
-                    <a:p>
-                      <a:pPr algn="r">
-                        <a:defRPr sz="1100">
-                          <a:solidFill>
-                            <a:srgbClr val="2D2D3D"/>
-                          </a:solidFill>
-                          <a:latin typeface="Calibri"/>
-                        </a:defRPr>
-                      </a:pPr>
-                      <a:r>
-                        <a:t>−1.6</a:t>
-                      </a:r>
-                    </a:p>
-                  </a:txBody>
-                  <a:tcPr>
-                    <a:solidFill>
-                      <a:srgbClr val="FFFFFF"/>
-                    </a:solidFill>
-                  </a:tcPr>
-                </a:tc>
-              </a:tr>
-              <a:tr h="320039">
-                <a:tc>
-                  <a:txBody>
-                    <a:bodyPr/>
-                    <a:lstStyle/>
-                    <a:p>
-                      <a:pPr algn="l">
-                        <a:defRPr sz="1100">
-                          <a:solidFill>
-                            <a:srgbClr val="2D2D3D"/>
-                          </a:solidFill>
-                          <a:latin typeface="Calibri"/>
-                        </a:defRPr>
-                      </a:pPr>
-                      <a:r>
-                        <a:t>B−</a:t>
-                      </a:r>
-                    </a:p>
-                  </a:txBody>
-                  <a:tcPr>
-                    <a:solidFill>
-                      <a:srgbClr val="E8EBF5"/>
-                    </a:solidFill>
-                  </a:tcPr>
-                </a:tc>
-                <a:tc>
-                  <a:txBody>
-                    <a:bodyPr/>
-                    <a:lstStyle/>
-                    <a:p>
-                      <a:pPr algn="r">
-                        <a:defRPr sz="1100">
-                          <a:solidFill>
-                            <a:srgbClr val="2D2D3D"/>
-                          </a:solidFill>
-                          <a:latin typeface="Calibri"/>
-                        </a:defRPr>
-                      </a:pPr>
-                      <a:r>
-                        <a:t>90.33</a:t>
-                      </a:r>
-                    </a:p>
-                  </a:txBody>
-                  <a:tcPr>
-                    <a:solidFill>
-                      <a:srgbClr val="E8EBF5"/>
-                    </a:solidFill>
-                  </a:tcPr>
-                </a:tc>
-                <a:tc>
-                  <a:txBody>
-                    <a:bodyPr/>
-                    <a:lstStyle/>
-                    <a:p>
-                      <a:pPr algn="r">
-                        <a:defRPr sz="1100">
-                          <a:solidFill>
-                            <a:srgbClr val="2D2D3D"/>
-                          </a:solidFill>
-                          <a:latin typeface="Calibri"/>
-                        </a:defRPr>
-                      </a:pPr>
-                      <a:r>
-                        <a:t>83.45</a:t>
-                      </a:r>
-                    </a:p>
-                  </a:txBody>
-                  <a:tcPr>
-                    <a:solidFill>
-                      <a:srgbClr val="E8EBF5"/>
-                    </a:solidFill>
-                  </a:tcPr>
-                </a:tc>
-                <a:tc>
-                  <a:txBody>
-                    <a:bodyPr/>
-                    <a:lstStyle/>
-                    <a:p>
-                      <a:pPr algn="r">
-                        <a:defRPr sz="1100">
-                          <a:solidFill>
-                            <a:srgbClr val="2D2D3D"/>
-                          </a:solidFill>
-                          <a:latin typeface="Calibri"/>
-                        </a:defRPr>
-                      </a:pPr>
-                      <a:r>
-                        <a:t>87.28</a:t>
-                      </a:r>
-                    </a:p>
-                  </a:txBody>
-                  <a:tcPr>
-                    <a:solidFill>
-                      <a:srgbClr val="E8EBF5"/>
-                    </a:solidFill>
-                  </a:tcPr>
-                </a:tc>
-                <a:tc>
-                  <a:txBody>
-                    <a:bodyPr/>
-                    <a:lstStyle/>
-                    <a:p>
-                      <a:pPr algn="r">
-                        <a:defRPr sz="1100">
-                          <a:solidFill>
-                            <a:srgbClr val="2D2D3D"/>
-                          </a:solidFill>
-                          <a:latin typeface="Calibri"/>
-                        </a:defRPr>
-                      </a:pPr>
-                      <a:r>
-                        <a:t>82.39</a:t>
-                      </a:r>
-                    </a:p>
-                  </a:txBody>
-                  <a:tcPr>
-                    <a:solidFill>
-                      <a:srgbClr val="E8EBF5"/>
-                    </a:solidFill>
-                  </a:tcPr>
-                </a:tc>
-                <a:tc>
-                  <a:txBody>
-                    <a:bodyPr/>
-                    <a:lstStyle/>
-                    <a:p>
-                      <a:pPr algn="r">
-                        <a:defRPr sz="1100">
-                          <a:solidFill>
-                            <a:srgbClr val="2D2D3D"/>
-                          </a:solidFill>
-                          <a:latin typeface="Calibri"/>
-                        </a:defRPr>
-                      </a:pPr>
-                      <a:r>
-                        <a:t>−6.9</a:t>
-                      </a:r>
-                    </a:p>
-                  </a:txBody>
-                  <a:tcPr>
-                    <a:solidFill>
-                      <a:srgbClr val="E8EBF5"/>
-                    </a:solidFill>
-                  </a:tcPr>
-                </a:tc>
-                <a:tc>
-                  <a:txBody>
-                    <a:bodyPr/>
-                    <a:lstStyle/>
-                    <a:p>
-                      <a:pPr algn="r">
-                        <a:defRPr sz="1100">
-                          <a:solidFill>
-                            <a:srgbClr val="2D2D3D"/>
-                          </a:solidFill>
-                          <a:latin typeface="Calibri"/>
-                        </a:defRPr>
-                      </a:pPr>
-                      <a:r>
-                        <a:t>−4.9</a:t>
-                      </a:r>
-                    </a:p>
-                  </a:txBody>
-                  <a:tcPr>
-                    <a:solidFill>
-                      <a:srgbClr val="E8EBF5"/>
-                    </a:solidFill>
-                  </a:tcPr>
-                </a:tc>
-              </a:tr>
-              <a:tr h="320044">
-                <a:tc>
-                  <a:txBody>
-                    <a:bodyPr/>
-                    <a:lstStyle/>
-                    <a:p>
-                      <a:pPr algn="l">
-                        <a:defRPr sz="1100">
-                          <a:solidFill>
-                            <a:srgbClr val="2D2D3D"/>
-                          </a:solidFill>
-                          <a:latin typeface="Calibri"/>
-                        </a:defRPr>
-                      </a:pPr>
-                      <a:r>
-                        <a:t>CCC</a:t>
-                      </a:r>
-                    </a:p>
-                  </a:txBody>
-                  <a:tcPr>
-                    <a:solidFill>
-                      <a:srgbClr val="FFFFFF"/>
-                    </a:solidFill>
-                  </a:tcPr>
-                </a:tc>
-                <a:tc>
-                  <a:txBody>
-                    <a:bodyPr/>
-                    <a:lstStyle/>
-                    <a:p>
-                      <a:pPr algn="r">
-                        <a:defRPr sz="1100">
-                          <a:solidFill>
-                            <a:srgbClr val="2D2D3D"/>
-                          </a:solidFill>
-                          <a:latin typeface="Calibri"/>
-                        </a:defRPr>
-                      </a:pPr>
-                      <a:r>
-                        <a:t>76.13</a:t>
-                      </a:r>
-                    </a:p>
-                  </a:txBody>
-                  <a:tcPr>
-                    <a:solidFill>
-                      <a:srgbClr val="FFFFFF"/>
-                    </a:solidFill>
-                  </a:tcPr>
-                </a:tc>
-                <a:tc>
-                  <a:txBody>
-                    <a:bodyPr/>
-                    <a:lstStyle/>
-                    <a:p>
-                      <a:pPr algn="r">
-                        <a:defRPr sz="1100">
-                          <a:solidFill>
-                            <a:srgbClr val="2D2D3D"/>
-                          </a:solidFill>
-                          <a:latin typeface="Calibri"/>
-                        </a:defRPr>
-                      </a:pPr>
-                      <a:r>
-                        <a:t>67.34</a:t>
-                      </a:r>
-                    </a:p>
-                  </a:txBody>
-                  <a:tcPr>
-                    <a:solidFill>
-                      <a:srgbClr val="FFFFFF"/>
-                    </a:solidFill>
-                  </a:tcPr>
-                </a:tc>
-                <a:tc>
-                  <a:txBody>
-                    <a:bodyPr/>
-                    <a:lstStyle/>
-                    <a:p>
-                      <a:pPr algn="r">
-                        <a:defRPr sz="1100">
-                          <a:solidFill>
-                            <a:srgbClr val="2D2D3D"/>
-                          </a:solidFill>
-                          <a:latin typeface="Calibri"/>
-                        </a:defRPr>
-                      </a:pPr>
-                      <a:r>
-                        <a:t>63.60</a:t>
-                      </a:r>
-                    </a:p>
-                  </a:txBody>
-                  <a:tcPr>
-                    <a:solidFill>
-                      <a:srgbClr val="FFFFFF"/>
-                    </a:solidFill>
-                  </a:tcPr>
-                </a:tc>
-                <a:tc>
-                  <a:txBody>
-                    <a:bodyPr/>
-                    <a:lstStyle/>
-                    <a:p>
-                      <a:pPr algn="r">
-                        <a:defRPr sz="1100">
-                          <a:solidFill>
-                            <a:srgbClr val="2D2D3D"/>
-                          </a:solidFill>
-                          <a:latin typeface="Calibri"/>
-                        </a:defRPr>
-                      </a:pPr>
-                      <a:r>
-                        <a:t>57.43</a:t>
-                      </a:r>
-                    </a:p>
-                  </a:txBody>
-                  <a:tcPr>
-                    <a:solidFill>
-                      <a:srgbClr val="FFFFFF"/>
-                    </a:solidFill>
-                  </a:tcPr>
-                </a:tc>
-                <a:tc>
-                  <a:txBody>
-                    <a:bodyPr/>
-                    <a:lstStyle/>
-                    <a:p>
-                      <a:pPr algn="r">
-                        <a:defRPr sz="1100">
-                          <a:solidFill>
-                            <a:srgbClr val="2D2D3D"/>
-                          </a:solidFill>
-                          <a:latin typeface="Calibri"/>
-                        </a:defRPr>
-                      </a:pPr>
-                      <a:r>
-                        <a:t>−8.8</a:t>
-                      </a:r>
-                    </a:p>
-                  </a:txBody>
-                  <a:tcPr>
-                    <a:solidFill>
-                      <a:srgbClr val="FFFFFF"/>
-                    </a:solidFill>
-                  </a:tcPr>
-                </a:tc>
-                <a:tc>
-                  <a:txBody>
-                    <a:bodyPr/>
-                    <a:lstStyle/>
-                    <a:p>
-                      <a:pPr algn="r">
-                        <a:defRPr sz="1100">
-                          <a:solidFill>
-                            <a:srgbClr val="2D2D3D"/>
-                          </a:solidFill>
-                          <a:latin typeface="Calibri"/>
-                        </a:defRPr>
-                      </a:pPr>
-                      <a:r>
-                        <a:t>−6.2</a:t>
+                        <a:t>1.2×</a:t>
                       </a:r>
                     </a:p>
                   </a:txBody>
@@ -12105,7 +11960,7 @@
               </a:defRPr>
             </a:pPr>
             <a:r>
-              <a:t>Δ = PIK price minus Cash price (in points). HR = hazard-rate model. MC = Merton Monte Carlo.</a:t>
+              <a:t>ΔPrice = PIK minus Cash (points). HR 5Y PD = market-implied. MC DefRate = simulation default rate.</a:t>
             </a:r>
           </a:p>
         </p:txBody>
@@ -12136,7 +11991,7 @@
               <a:spcAft>
                 <a:spcPts val="800"/>
               </a:spcAft>
-              <a:defRPr sz="1400">
+              <a:defRPr sz="1300">
                 <a:solidFill>
                   <a:srgbClr val="2D2D3D"/>
                 </a:solidFill>
@@ -12144,7 +11999,7 @@
               </a:defRPr>
             </a:pPr>
             <a:r>
-              <a:t>The HR model always prices PIK below cash (negative Δ). It sees only the concentrated maturity exposure.</a:t>
+              <a:t>The HR model uses market-implied defaults (including risk premium) → PIK always costs. The MC model uses historical PDs for barriers → fewer defaults → PIK compounding survives</a:t>
             </a:r>
           </a:p>
           <a:p>
@@ -12152,7 +12007,7 @@
               <a:spcAft>
                 <a:spcPts val="800"/>
               </a:spcAft>
-              <a:defRPr sz="1400">
+              <a:defRPr sz="1300">
                 <a:solidFill>
                   <a:srgbClr val="2D2D3D"/>
                 </a:solidFill>
@@ -12160,7 +12015,7 @@
               </a:defRPr>
             </a:pPr>
             <a:r>
-              <a:t>The MC model prices PIK ABOVE cash for BB+/BB− (positive Δ). Rare defaults mean PIK compounding is a net benefit.</a:t>
+              <a:t>For BB+: the HR model sees 3.6× more defaults than the MC model. This gap drives the sign reversal in PIK pricing</a:t>
             </a:r>
           </a:p>
           <a:p>
@@ -12168,7 +12023,7 @@
               <a:spcAft>
                 <a:spcPts val="800"/>
               </a:spcAft>
-              <a:defRPr sz="1400">
+              <a:defRPr sz="1300">
                 <a:solidFill>
                   <a:srgbClr val="2D2D3D"/>
                 </a:solidFill>
@@ -12176,7 +12031,7 @@
               </a:defRPr>
             </a:pPr>
             <a:r>
-              <a:t>For stressed credits (B−, CCC), both models agree PIK is cheaper, but the gap narrows because MC includes the leverage spiral that the HR model misses.</a:t>
+              <a:t>For CCC: both models see similar default rates (ratio 1.2×). The PIK penalty is robust regardless of calibration</a:t>
             </a:r>
           </a:p>
           <a:p>
@@ -12184,7 +12039,7 @@
               <a:spcAft>
                 <a:spcPts val="800"/>
               </a:spcAft>
-              <a:defRPr sz="1400">
+              <a:defRPr sz="1300">
                 <a:solidFill>
                   <a:srgbClr val="2D2D3D"/>
                 </a:solidFill>
@@ -12192,7 +12047,7 @@
               </a:defRPr>
             </a:pPr>
             <a:r>
-              <a:t>The sign reversal for strong credits is the key insight: a flat hazard model cannot capture this dynamic.</a:t>
+              <a:t>The practical implication: for strong credits, the PIK premium/discount is small either way (±60bp). For weak credits, it's large (+100–260bp) and model choice barely matters</a:t>
             </a:r>
           </a:p>
         </p:txBody>
@@ -12205,8 +12060,8 @@
         </p:nvSpPr>
         <p:spPr>
           <a:xfrm>
-            <a:off x="1371600" y="5669280"/>
-            <a:ext cx="6400800" cy="548640"/>
+            <a:off x="914400" y="5669280"/>
+            <a:ext cx="7315200" cy="548640"/>
           </a:xfrm>
           <a:prstGeom prst="roundRect">
             <a:avLst/>
@@ -12245,7 +12100,7 @@
               </a:defRPr>
             </a:pPr>
             <a:r>
-              <a:t>The structural model captures two things the hazard model cannot: (1) the compounding benefit when defaults are rare, and (2) the feedback spiral when defaults are likely.</a:t>
+              <a:t>Model choice matters most where the answer matters least (strong credits). Where the premium is large and actionable (weak credits), both models agree.</a:t>
             </a:r>
           </a:p>
         </p:txBody>
@@ -12485,7 +12340,7 @@
               </a:defRPr>
             </a:pPr>
             <a:r>
-              <a:t>PIK BENEFITS INVESTOR</a:t>
+              <a:t>LOW IMPACT ZONE</a:t>
             </a:r>
           </a:p>
         </p:txBody>
@@ -12560,7 +12415,7 @@
               </a:defRPr>
             </a:pPr>
             <a:r>
-              <a:t>PIK Z-spread is BELOW cash</a:t>
+              <a:t>PIK premium is small (±60bp)</a:t>
             </a:r>
           </a:p>
           <a:p>
@@ -12576,7 +12431,7 @@
               </a:defRPr>
             </a:pPr>
             <a:r>
-              <a:t>Compounding benefit dominates</a:t>
+              <a:t>Sign is calibration-dependent</a:t>
             </a:r>
           </a:p>
           <a:p>
@@ -12608,7 +12463,7 @@
               </a:defRPr>
             </a:pPr>
             <a:r>
-              <a:t>Price PIK at or inside cash</a:t>
+              <a:t>PIK vs cash difference is minor</a:t>
             </a:r>
           </a:p>
         </p:txBody>
@@ -13064,7 +12919,7 @@
                         </a:defRPr>
                       </a:pPr>
                       <a:r>
-                        <a:t>PIK Benefits</a:t>
+                        <a:t>Low Impact</a:t>
                       </a:r>
                     </a:p>
                   </a:txBody>
@@ -13162,7 +13017,7 @@
                         </a:defRPr>
                       </a:pPr>
                       <a:r>
-                        <a:t>−60 to −20bp</a:t>
+                        <a:t>±60bp (model-dep.)</a:t>
                       </a:r>
                     </a:p>
                   </a:txBody>
@@ -13260,7 +13115,7 @@
                         </a:defRPr>
                       </a:pPr>
                       <a:r>
-                        <a:t>No — PIK trades inside</a:t>
+                        <a:t>Either model adequate</a:t>
                       </a:r>
                     </a:p>
                   </a:txBody>
@@ -13456,7 +13311,7 @@
                         </a:defRPr>
                       </a:pPr>
                       <a:r>
-                        <a:t>Maturity extension risk</a:t>
+                        <a:t>Calibration assumption</a:t>
                       </a:r>
                     </a:p>
                   </a:txBody>
@@ -13743,7 +13598,7 @@
               </a:defRPr>
             </a:pPr>
             <a:r>
-              <a:t>PIK premium depends entirely on credit quality</a:t>
+              <a:t>PIK premium is non-linear and credit-quality-dependent</a:t>
             </a:r>
           </a:p>
         </p:txBody>
@@ -13779,7 +13634,7 @@
               </a:defRPr>
             </a:pPr>
             <a:r>
-              <a:t>For strong credits (BB+/BB−), PIK can actually trade tighter than cash — compounding benefits outweigh rare defaults. For stressed credits (CCC), the premium exceeds +260bp.</a:t>
+              <a:t>For strong credits (BB+/BB−), the premium is small (±60bp) and its sign depends on calibration. For stressed credits (CCC), the premium exceeds +260bp and is robust across models.</a:t>
             </a:r>
           </a:p>
         </p:txBody>
@@ -13867,7 +13722,7 @@
               </a:defRPr>
             </a:pPr>
             <a:r>
-              <a:t>Simple hazard models get the sign wrong for strong credits</a:t>
+              <a:t>Model disagreement is largest where the stakes are smallest</a:t>
             </a:r>
           </a:p>
         </p:txBody>
@@ -13903,7 +13758,7 @@
               </a:defRPr>
             </a:pPr>
             <a:r>
-              <a:t>The flat-λ model always penalises PIK. The structural model shows PIK trades ABOVE cash for BB+. The crossover is near 300bp market spread.</a:t>
+              <a:t>For strong credits, models disagree on the sign but the magnitude is small. For weak credits, models agree: PIK premium is large and the feedback spiral dominates.</a:t>
             </a:r>
           </a:p>
         </p:txBody>
@@ -14115,7 +13970,7 @@
               </a:defRPr>
             </a:pPr>
             <a:r>
-              <a:t>Above ~500bp market spread, structural modelling is essential</a:t>
+              <a:t>Above ~400bp market spread, structural modelling is essential</a:t>
             </a:r>
           </a:p>
         </p:txBody>
@@ -14151,7 +14006,7 @@
               </a:defRPr>
             </a:pPr>
             <a:r>
-              <a:t>In the structural risk zone, the feedback loop dominates pricing. A spread bump approach will materially misprice PIK risk.</a:t>
+              <a:t>In the structural risk zone, the feedback loop dominates pricing regardless of calibration. A flat spread bump approach will materially misprice PIK risk.</a:t>
             </a:r>
           </a:p>
         </p:txBody>
@@ -14558,7 +14413,7 @@
               </a:defRPr>
             </a:pPr>
             <a:r>
-              <a:t>For strong credits (BB+): PIK can trade tighter</a:t>
+              <a:t>For strong credits (BB+): PIK premium is small (±60bp) and sign is model-dependent</a:t>
             </a:r>
           </a:p>
           <a:p>
@@ -14574,7 +14429,7 @@
               </a:defRPr>
             </a:pPr>
             <a:r>
-              <a:t>For stressed credits (CCC): PIK premium &gt; +260bp</a:t>
+              <a:t>For stressed credits (CCC): PIK premium &gt; +260bp, robust across models</a:t>
             </a:r>
           </a:p>
           <a:p>
@@ -14590,7 +14445,7 @@
               </a:defRPr>
             </a:pPr>
             <a:r>
-              <a:t>Below ~300bp market spread: PIK actually benefits the investor</a:t>
+              <a:t>The non-linearity means flat spread bumps are dangerous</a:t>
             </a:r>
           </a:p>
         </p:txBody>
@@ -14643,7 +14498,7 @@
               </a:defRPr>
             </a:pPr>
             <a:r>
-              <a:t>The answer depends on credit quality in a way that is impossible to guess without a model. The premium can even be negative.</a:t>
+              <a:t>The answer depends on credit quality in a way that is impossible to guess without a model. The premium is non-linear and, for strong credits, depends on calibration assumptions.</a:t>
             </a:r>
           </a:p>
         </p:txBody>
@@ -18118,7 +17973,7 @@
               </a:defRPr>
             </a:pPr>
             <a:r>
-              <a:t>What the simple model predicts — but is it right?</a:t>
+              <a:t>Risk-neutral pricing: hazard rates from market spreads</a:t>
             </a:r>
           </a:p>
         </p:txBody>
@@ -18954,7 +18809,7 @@
               </a:defRPr>
             </a:pPr>
             <a:r>
-              <a:t>Under fixed hazard rates, the model predicts PIK always trades below cash — concentrated maturity exposure penalises PIK at every credit level</a:t>
+              <a:t>Under risk-neutral hazard rates (calibrated from market spreads), PIK always prices below cash — concentrated maturity exposure penalises PIK at every credit level</a:t>
             </a:r>
           </a:p>
           <a:p>
@@ -18970,7 +18825,7 @@
               </a:defRPr>
             </a:pPr>
             <a:r>
-              <a:t>The predicted gap widens with credit risk: from −2.5 pts (BB+) to −8.8 pts (CCC)</a:t>
+              <a:t>The gap widens with credit risk: from −2.5 pts (BB+) to −8.8 pts (CCC)</a:t>
             </a:r>
           </a:p>
           <a:p>
@@ -18986,7 +18841,7 @@
               </a:defRPr>
             </a:pPr>
             <a:r>
-              <a:t>But this conclusion turns out to be WRONG for strong credits. A structural model (next section) shows PIK actually trades ABOVE cash for BB+ and BB− issuers</a:t>
+              <a:t>Note: market spreads embed a credit risk premium above expected losses. For BB+ the spread (85bp) implies ~7% 5Y default prob, versus the historical rate of ~1%</a:t>
             </a:r>
           </a:p>
         </p:txBody>
@@ -19039,7 +18894,7 @@
               </a:defRPr>
             </a:pPr>
             <a:r>
-              <a:t>This is the simple model’s answer — not the final answer. The structural model will reverse the sign for strong credits, where rare defaults make PIK compounding a net benefit.</a:t>
+              <a:t>Under risk-neutral pricing, PIK always costs the investor. The question is whether the structural model — which uses historical PDs — tells a different story.</a:t>
             </a:r>
           </a:p>
         </p:txBody>
@@ -19154,7 +19009,7 @@
               </a:defRPr>
             </a:pPr>
             <a:r>
-              <a:t>What the Simple Model Misses</a:t>
+              <a:t>The Calibration Gap</a:t>
             </a:r>
           </a:p>
         </p:txBody>
@@ -19190,7 +19045,7 @@
               </a:defRPr>
             </a:pPr>
             <a:r>
-              <a:t>Hazard-rate vs structural: the price gap</a:t>
+              <a:t>Why two models disagree on PIK for strong credits</a:t>
             </a:r>
           </a:p>
         </p:txBody>
@@ -19240,8 +19095,8 @@
           <p:nvPr/>
         </p:nvGraphicFramePr>
         <p:xfrm>
-          <a:off x="1371600" y="1280160"/>
-          <a:ext cx="5577840" cy="1920239"/>
+          <a:off x="731520" y="1188720"/>
+          <a:ext cx="6675120" cy="1920239"/>
         </p:xfrm>
         <a:graphic>
           <a:graphicData uri="http://schemas.openxmlformats.org/drawingml/2006/table">
@@ -19253,7 +19108,8 @@
                 <a:gridCol w="2286000"/>
                 <a:gridCol w="1097280"/>
                 <a:gridCol w="1097280"/>
-                <a:gridCol w="1097280"/>
+                <a:gridCol w="1280160"/>
+                <a:gridCol w="914400"/>
               </a:tblGrid>
               <a:tr h="320039">
                 <a:tc>
@@ -19262,7 +19118,7 @@
                     <a:lstStyle/>
                     <a:p>
                       <a:pPr algn="ctr">
-                        <a:defRPr sz="1300" b="1">
+                        <a:defRPr sz="1200" b="1">
                           <a:solidFill>
                             <a:srgbClr val="FFFFFF"/>
                           </a:solidFill>
@@ -19286,7 +19142,7 @@
                     <a:lstStyle/>
                     <a:p>
                       <a:pPr algn="ctr">
-                        <a:defRPr sz="1300" b="1">
+                        <a:defRPr sz="1200" b="1">
                           <a:solidFill>
                             <a:srgbClr val="FFFFFF"/>
                           </a:solidFill>
@@ -19294,7 +19150,7 @@
                         </a:defRPr>
                       </a:pPr>
                       <a:r>
-                        <a:t>HR ΔPrice</a:t>
+                        <a:t>Mkt Sprd</a:t>
                       </a:r>
                     </a:p>
                   </a:txBody>
@@ -19310,7 +19166,7 @@
                     <a:lstStyle/>
                     <a:p>
                       <a:pPr algn="ctr">
-                        <a:defRPr sz="1300" b="1">
+                        <a:defRPr sz="1200" b="1">
                           <a:solidFill>
                             <a:srgbClr val="FFFFFF"/>
                           </a:solidFill>
@@ -19318,7 +19174,7 @@
                         </a:defRPr>
                       </a:pPr>
                       <a:r>
-                        <a:t>MC ΔPrice</a:t>
+                        <a:t>HR 5Y PD</a:t>
                       </a:r>
                     </a:p>
                   </a:txBody>
@@ -19334,7 +19190,7 @@
                     <a:lstStyle/>
                     <a:p>
                       <a:pPr algn="ctr">
-                        <a:defRPr sz="1300" b="1">
+                        <a:defRPr sz="1200" b="1">
                           <a:solidFill>
                             <a:srgbClr val="FFFFFF"/>
                           </a:solidFill>
@@ -19342,7 +19198,31 @@
                         </a:defRPr>
                       </a:pPr>
                       <a:r>
-                        <a:t>Gap</a:t>
+                        <a:t>Hist 5Y PD</a:t>
+                      </a:r>
+                    </a:p>
+                  </a:txBody>
+                  <a:tcPr>
+                    <a:solidFill>
+                      <a:srgbClr val="2C3E6B"/>
+                    </a:solidFill>
+                  </a:tcPr>
+                </a:tc>
+                <a:tc>
+                  <a:txBody>
+                    <a:bodyPr/>
+                    <a:lstStyle/>
+                    <a:p>
+                      <a:pPr algn="ctr">
+                        <a:defRPr sz="1200" b="1">
+                          <a:solidFill>
+                            <a:srgbClr val="FFFFFF"/>
+                          </a:solidFill>
+                          <a:latin typeface="Calibri"/>
+                        </a:defRPr>
+                      </a:pPr>
+                      <a:r>
+                        <a:t>Ratio</a:t>
                       </a:r>
                     </a:p>
                   </a:txBody>
@@ -19360,7 +19240,7 @@
                     <a:lstStyle/>
                     <a:p>
                       <a:pPr algn="l">
-                        <a:defRPr sz="1300">
+                        <a:defRPr sz="1200">
                           <a:solidFill>
                             <a:srgbClr val="2D2D3D"/>
                           </a:solidFill>
@@ -19384,15 +19264,15 @@
                     <a:lstStyle/>
                     <a:p>
                       <a:pPr algn="r">
-                        <a:defRPr sz="1300">
-                          <a:solidFill>
-                            <a:srgbClr val="2D2D3D"/>
-                          </a:solidFill>
-                          <a:latin typeface="Calibri"/>
-                        </a:defRPr>
-                      </a:pPr>
-                      <a:r>
-                        <a:t>−2.46</a:t>
+                        <a:defRPr sz="1200">
+                          <a:solidFill>
+                            <a:srgbClr val="2D2D3D"/>
+                          </a:solidFill>
+                          <a:latin typeface="Calibri"/>
+                        </a:defRPr>
+                      </a:pPr>
+                      <a:r>
+                        <a:t>85bp</a:t>
                       </a:r>
                     </a:p>
                   </a:txBody>
@@ -19408,15 +19288,15 @@
                     <a:lstStyle/>
                     <a:p>
                       <a:pPr algn="r">
-                        <a:defRPr sz="1300">
-                          <a:solidFill>
-                            <a:srgbClr val="2D2D3D"/>
-                          </a:solidFill>
-                          <a:latin typeface="Calibri"/>
-                        </a:defRPr>
-                      </a:pPr>
-                      <a:r>
-                        <a:t>+2.98</a:t>
+                        <a:defRPr sz="1200">
+                          <a:solidFill>
+                            <a:srgbClr val="2D2D3D"/>
+                          </a:solidFill>
+                          <a:latin typeface="Calibri"/>
+                        </a:defRPr>
+                      </a:pPr>
+                      <a:r>
+                        <a:t>6.9%</a:t>
                       </a:r>
                     </a:p>
                   </a:txBody>
@@ -19432,15 +19312,39 @@
                     <a:lstStyle/>
                     <a:p>
                       <a:pPr algn="r">
-                        <a:defRPr sz="1300">
-                          <a:solidFill>
-                            <a:srgbClr val="2D2D3D"/>
-                          </a:solidFill>
-                          <a:latin typeface="Calibri"/>
-                        </a:defRPr>
-                      </a:pPr>
-                      <a:r>
-                        <a:t>5.4 pts</a:t>
+                        <a:defRPr sz="1200">
+                          <a:solidFill>
+                            <a:srgbClr val="2D2D3D"/>
+                          </a:solidFill>
+                          <a:latin typeface="Calibri"/>
+                        </a:defRPr>
+                      </a:pPr>
+                      <a:r>
+                        <a:t>1.0%</a:t>
+                      </a:r>
+                    </a:p>
+                  </a:txBody>
+                  <a:tcPr>
+                    <a:solidFill>
+                      <a:srgbClr val="FFFFFF"/>
+                    </a:solidFill>
+                  </a:tcPr>
+                </a:tc>
+                <a:tc>
+                  <a:txBody>
+                    <a:bodyPr/>
+                    <a:lstStyle/>
+                    <a:p>
+                      <a:pPr algn="r">
+                        <a:defRPr sz="1200">
+                          <a:solidFill>
+                            <a:srgbClr val="2D2D3D"/>
+                          </a:solidFill>
+                          <a:latin typeface="Calibri"/>
+                        </a:defRPr>
+                      </a:pPr>
+                      <a:r>
+                        <a:t>6.9×</a:t>
                       </a:r>
                     </a:p>
                   </a:txBody>
@@ -19458,7 +19362,7 @@
                     <a:lstStyle/>
                     <a:p>
                       <a:pPr algn="l">
-                        <a:defRPr sz="1300">
+                        <a:defRPr sz="1200">
                           <a:solidFill>
                             <a:srgbClr val="2D2D3D"/>
                           </a:solidFill>
@@ -19482,15 +19386,15 @@
                     <a:lstStyle/>
                     <a:p>
                       <a:pPr algn="r">
-                        <a:defRPr sz="1300">
-                          <a:solidFill>
-                            <a:srgbClr val="2D2D3D"/>
-                          </a:solidFill>
-                          <a:latin typeface="Calibri"/>
-                        </a:defRPr>
-                      </a:pPr>
-                      <a:r>
-                        <a:t>−3.80</a:t>
+                        <a:defRPr sz="1200">
+                          <a:solidFill>
+                            <a:srgbClr val="2D2D3D"/>
+                          </a:solidFill>
+                          <a:latin typeface="Calibri"/>
+                        </a:defRPr>
+                      </a:pPr>
+                      <a:r>
+                        <a:t>210bp</a:t>
                       </a:r>
                     </a:p>
                   </a:txBody>
@@ -19506,15 +19410,15 @@
                     <a:lstStyle/>
                     <a:p>
                       <a:pPr algn="r">
-                        <a:defRPr sz="1300">
-                          <a:solidFill>
-                            <a:srgbClr val="2D2D3D"/>
-                          </a:solidFill>
-                          <a:latin typeface="Calibri"/>
-                        </a:defRPr>
-                      </a:pPr>
-                      <a:r>
-                        <a:t>+1.05</a:t>
+                        <a:defRPr sz="1200">
+                          <a:solidFill>
+                            <a:srgbClr val="2D2D3D"/>
+                          </a:solidFill>
+                          <a:latin typeface="Calibri"/>
+                        </a:defRPr>
+                      </a:pPr>
+                      <a:r>
+                        <a:t>15.5%</a:t>
                       </a:r>
                     </a:p>
                   </a:txBody>
@@ -19530,15 +19434,39 @@
                     <a:lstStyle/>
                     <a:p>
                       <a:pPr algn="r">
-                        <a:defRPr sz="1300">
-                          <a:solidFill>
-                            <a:srgbClr val="2D2D3D"/>
-                          </a:solidFill>
-                          <a:latin typeface="Calibri"/>
-                        </a:defRPr>
-                      </a:pPr>
-                      <a:r>
-                        <a:t>4.9 pts</a:t>
+                        <a:defRPr sz="1200">
+                          <a:solidFill>
+                            <a:srgbClr val="2D2D3D"/>
+                          </a:solidFill>
+                          <a:latin typeface="Calibri"/>
+                        </a:defRPr>
+                      </a:pPr>
+                      <a:r>
+                        <a:t>4.9%</a:t>
+                      </a:r>
+                    </a:p>
+                  </a:txBody>
+                  <a:tcPr>
+                    <a:solidFill>
+                      <a:srgbClr val="E8EBF5"/>
+                    </a:solidFill>
+                  </a:tcPr>
+                </a:tc>
+                <a:tc>
+                  <a:txBody>
+                    <a:bodyPr/>
+                    <a:lstStyle/>
+                    <a:p>
+                      <a:pPr algn="r">
+                        <a:defRPr sz="1200">
+                          <a:solidFill>
+                            <a:srgbClr val="2D2D3D"/>
+                          </a:solidFill>
+                          <a:latin typeface="Calibri"/>
+                        </a:defRPr>
+                      </a:pPr>
+                      <a:r>
+                        <a:t>3.2×</a:t>
                       </a:r>
                     </a:p>
                   </a:txBody>
@@ -19556,7 +19484,7 @@
                     <a:lstStyle/>
                     <a:p>
                       <a:pPr algn="l">
-                        <a:defRPr sz="1300">
+                        <a:defRPr sz="1200">
                           <a:solidFill>
                             <a:srgbClr val="2D2D3D"/>
                           </a:solidFill>
@@ -19580,15 +19508,15 @@
                     <a:lstStyle/>
                     <a:p>
                       <a:pPr algn="r">
-                        <a:defRPr sz="1300">
-                          <a:solidFill>
-                            <a:srgbClr val="2D2D3D"/>
-                          </a:solidFill>
-                          <a:latin typeface="Calibri"/>
-                        </a:defRPr>
-                      </a:pPr>
-                      <a:r>
-                        <a:t>−5.32</a:t>
+                        <a:defRPr sz="1200">
+                          <a:solidFill>
+                            <a:srgbClr val="2D2D3D"/>
+                          </a:solidFill>
+                          <a:latin typeface="Calibri"/>
+                        </a:defRPr>
+                      </a:pPr>
+                      <a:r>
+                        <a:t>390bp</a:t>
                       </a:r>
                     </a:p>
                   </a:txBody>
@@ -19604,15 +19532,15 @@
                     <a:lstStyle/>
                     <a:p>
                       <a:pPr algn="r">
-                        <a:defRPr sz="1300">
-                          <a:solidFill>
-                            <a:srgbClr val="2D2D3D"/>
-                          </a:solidFill>
-                          <a:latin typeface="Calibri"/>
-                        </a:defRPr>
-                      </a:pPr>
-                      <a:r>
-                        <a:t>−1.61</a:t>
+                        <a:defRPr sz="1200">
+                          <a:solidFill>
+                            <a:srgbClr val="2D2D3D"/>
+                          </a:solidFill>
+                          <a:latin typeface="Calibri"/>
+                        </a:defRPr>
+                      </a:pPr>
+                      <a:r>
+                        <a:t>25.6%</a:t>
                       </a:r>
                     </a:p>
                   </a:txBody>
@@ -19628,15 +19556,39 @@
                     <a:lstStyle/>
                     <a:p>
                       <a:pPr algn="r">
-                        <a:defRPr sz="1300">
-                          <a:solidFill>
-                            <a:srgbClr val="2D2D3D"/>
-                          </a:solidFill>
-                          <a:latin typeface="Calibri"/>
-                        </a:defRPr>
-                      </a:pPr>
-                      <a:r>
-                        <a:t>3.7 pts</a:t>
+                        <a:defRPr sz="1200">
+                          <a:solidFill>
+                            <a:srgbClr val="2D2D3D"/>
+                          </a:solidFill>
+                          <a:latin typeface="Calibri"/>
+                        </a:defRPr>
+                      </a:pPr>
+                      <a:r>
+                        <a:t>11.8%</a:t>
+                      </a:r>
+                    </a:p>
+                  </a:txBody>
+                  <a:tcPr>
+                    <a:solidFill>
+                      <a:srgbClr val="FFFFFF"/>
+                    </a:solidFill>
+                  </a:tcPr>
+                </a:tc>
+                <a:tc>
+                  <a:txBody>
+                    <a:bodyPr/>
+                    <a:lstStyle/>
+                    <a:p>
+                      <a:pPr algn="r">
+                        <a:defRPr sz="1200">
+                          <a:solidFill>
+                            <a:srgbClr val="2D2D3D"/>
+                          </a:solidFill>
+                          <a:latin typeface="Calibri"/>
+                        </a:defRPr>
+                      </a:pPr>
+                      <a:r>
+                        <a:t>2.2×</a:t>
                       </a:r>
                     </a:p>
                   </a:txBody>
@@ -19654,7 +19606,7 @@
                     <a:lstStyle/>
                     <a:p>
                       <a:pPr algn="l">
-                        <a:defRPr sz="1300">
+                        <a:defRPr sz="1200">
                           <a:solidFill>
                             <a:srgbClr val="2D2D3D"/>
                           </a:solidFill>
@@ -19678,15 +19630,15 @@
                     <a:lstStyle/>
                     <a:p>
                       <a:pPr algn="r">
-                        <a:defRPr sz="1300">
-                          <a:solidFill>
-                            <a:srgbClr val="2D2D3D"/>
-                          </a:solidFill>
-                          <a:latin typeface="Calibri"/>
-                        </a:defRPr>
-                      </a:pPr>
-                      <a:r>
-                        <a:t>−6.88</a:t>
+                        <a:defRPr sz="1200">
+                          <a:solidFill>
+                            <a:srgbClr val="2D2D3D"/>
+                          </a:solidFill>
+                          <a:latin typeface="Calibri"/>
+                        </a:defRPr>
+                      </a:pPr>
+                      <a:r>
+                        <a:t>630bp</a:t>
                       </a:r>
                     </a:p>
                   </a:txBody>
@@ -19702,15 +19654,15 @@
                     <a:lstStyle/>
                     <a:p>
                       <a:pPr algn="r">
-                        <a:defRPr sz="1300">
-                          <a:solidFill>
-                            <a:srgbClr val="2D2D3D"/>
-                          </a:solidFill>
-                          <a:latin typeface="Calibri"/>
-                        </a:defRPr>
-                      </a:pPr>
-                      <a:r>
-                        <a:t>−4.89</a:t>
+                        <a:defRPr sz="1200">
+                          <a:solidFill>
+                            <a:srgbClr val="2D2D3D"/>
+                          </a:solidFill>
+                          <a:latin typeface="Calibri"/>
+                        </a:defRPr>
+                      </a:pPr>
+                      <a:r>
+                        <a:t>36.5%</a:t>
                       </a:r>
                     </a:p>
                   </a:txBody>
@@ -19726,15 +19678,39 @@
                     <a:lstStyle/>
                     <a:p>
                       <a:pPr algn="r">
-                        <a:defRPr sz="1300">
-                          <a:solidFill>
-                            <a:srgbClr val="2D2D3D"/>
-                          </a:solidFill>
-                          <a:latin typeface="Calibri"/>
-                        </a:defRPr>
-                      </a:pPr>
-                      <a:r>
-                        <a:t>2.0 pts</a:t>
+                        <a:defRPr sz="1200">
+                          <a:solidFill>
+                            <a:srgbClr val="2D2D3D"/>
+                          </a:solidFill>
+                          <a:latin typeface="Calibri"/>
+                        </a:defRPr>
+                      </a:pPr>
+                      <a:r>
+                        <a:t>24.0%</a:t>
+                      </a:r>
+                    </a:p>
+                  </a:txBody>
+                  <a:tcPr>
+                    <a:solidFill>
+                      <a:srgbClr val="E8EBF5"/>
+                    </a:solidFill>
+                  </a:tcPr>
+                </a:tc>
+                <a:tc>
+                  <a:txBody>
+                    <a:bodyPr/>
+                    <a:lstStyle/>
+                    <a:p>
+                      <a:pPr algn="r">
+                        <a:defRPr sz="1200">
+                          <a:solidFill>
+                            <a:srgbClr val="2D2D3D"/>
+                          </a:solidFill>
+                          <a:latin typeface="Calibri"/>
+                        </a:defRPr>
+                      </a:pPr>
+                      <a:r>
+                        <a:t>1.5×</a:t>
                       </a:r>
                     </a:p>
                   </a:txBody>
@@ -19752,7 +19728,7 @@
                     <a:lstStyle/>
                     <a:p>
                       <a:pPr algn="l">
-                        <a:defRPr sz="1300">
+                        <a:defRPr sz="1200">
                           <a:solidFill>
                             <a:srgbClr val="2D2D3D"/>
                           </a:solidFill>
@@ -19776,15 +19752,15 @@
                     <a:lstStyle/>
                     <a:p>
                       <a:pPr algn="r">
-                        <a:defRPr sz="1300">
-                          <a:solidFill>
-                            <a:srgbClr val="2D2D3D"/>
-                          </a:solidFill>
-                          <a:latin typeface="Calibri"/>
-                        </a:defRPr>
-                      </a:pPr>
-                      <a:r>
-                        <a:t>−8.79</a:t>
+                        <a:defRPr sz="1200">
+                          <a:solidFill>
+                            <a:srgbClr val="2D2D3D"/>
+                          </a:solidFill>
+                          <a:latin typeface="Calibri"/>
+                        </a:defRPr>
+                      </a:pPr>
+                      <a:r>
+                        <a:t>1050bp</a:t>
                       </a:r>
                     </a:p>
                   </a:txBody>
@@ -19800,15 +19776,15 @@
                     <a:lstStyle/>
                     <a:p>
                       <a:pPr algn="r">
-                        <a:defRPr sz="1300">
-                          <a:solidFill>
-                            <a:srgbClr val="2D2D3D"/>
-                          </a:solidFill>
-                          <a:latin typeface="Calibri"/>
-                        </a:defRPr>
-                      </a:pPr>
-                      <a:r>
-                        <a:t>−6.17</a:t>
+                        <a:defRPr sz="1200">
+                          <a:solidFill>
+                            <a:srgbClr val="2D2D3D"/>
+                          </a:solidFill>
+                          <a:latin typeface="Calibri"/>
+                        </a:defRPr>
+                      </a:pPr>
+                      <a:r>
+                        <a:t>52.0%</a:t>
                       </a:r>
                     </a:p>
                   </a:txBody>
@@ -19824,15 +19800,39 @@
                     <a:lstStyle/>
                     <a:p>
                       <a:pPr algn="r">
-                        <a:defRPr sz="1300">
-                          <a:solidFill>
-                            <a:srgbClr val="2D2D3D"/>
-                          </a:solidFill>
-                          <a:latin typeface="Calibri"/>
-                        </a:defRPr>
-                      </a:pPr>
-                      <a:r>
-                        <a:t>2.6 pts</a:t>
+                        <a:defRPr sz="1200">
+                          <a:solidFill>
+                            <a:srgbClr val="2D2D3D"/>
+                          </a:solidFill>
+                          <a:latin typeface="Calibri"/>
+                        </a:defRPr>
+                      </a:pPr>
+                      <a:r>
+                        <a:t>39.3%</a:t>
+                      </a:r>
+                    </a:p>
+                  </a:txBody>
+                  <a:tcPr>
+                    <a:solidFill>
+                      <a:srgbClr val="FFFFFF"/>
+                    </a:solidFill>
+                  </a:tcPr>
+                </a:tc>
+                <a:tc>
+                  <a:txBody>
+                    <a:bodyPr/>
+                    <a:lstStyle/>
+                    <a:p>
+                      <a:pPr algn="r">
+                        <a:defRPr sz="1200">
+                          <a:solidFill>
+                            <a:srgbClr val="2D2D3D"/>
+                          </a:solidFill>
+                          <a:latin typeface="Calibri"/>
+                        </a:defRPr>
+                      </a:pPr>
+                      <a:r>
+                        <a:t>1.3×</a:t>
                       </a:r>
                     </a:p>
                   </a:txBody>
@@ -19878,11 +19878,11 @@
               </a:defRPr>
             </a:pPr>
             <a:r>
-              <a:t>HR = hazard rate model (fixed λ).  MC = Merton Monte Carlo (structural model with feedback).</a:t>
+              <a:t>HR 5Y PD = implied from market spread.  Hist 5Y PD = from historical annual default rate.</a:t>
             </a:r>
             <a:br/>
             <a:r>
-              <a:t>ΔPrice = PIK price minus Cash price.</a:t>
+              <a:t>Ratio = how much the market ‘overstates’ default risk vs historical experience.</a:t>
             </a:r>
           </a:p>
         </p:txBody>
@@ -19895,7 +19895,7 @@
         </p:nvSpPr>
         <p:spPr>
           <a:xfrm>
-            <a:off x="457200" y="3931920"/>
+            <a:off x="457200" y="4023360"/>
             <a:ext cx="8229600" cy="1371600"/>
           </a:xfrm>
           <a:prstGeom prst="rect">
@@ -19921,7 +19921,7 @@
               </a:defRPr>
             </a:pPr>
             <a:r>
-              <a:t>For BB+: the HR model says PIK trades 2.5 pts cheaper. The MC model says PIK trades 3 pts ABOVE cash. Sign reversal!</a:t>
+              <a:t>Market spreads embed a risk premium — compensation for bearing credit risk beyond expected losses. For BB+, the spread implies 7×the historical default rate</a:t>
             </a:r>
           </a:p>
           <a:p>
@@ -19937,7 +19937,7 @@
               </a:defRPr>
             </a:pPr>
             <a:r>
-              <a:t>For strong credits, defaults are rare enough that PIK compounding is a net benefit — a fact that the simple model entirely misses</a:t>
+              <a:t>The HR model uses market-implied hazard → PIK always costs. The MC model uses historical PDs for barriers → few defaults → PIK compounding survives → PIK appears to benefit investors</a:t>
             </a:r>
           </a:p>
           <a:p>
@@ -19953,7 +19953,7 @@
               </a:defRPr>
             </a:pPr>
             <a:r>
-              <a:t>For weak credits, both models agree PIK is cheaper, but the MC model captures the structural feedback that amplifies the penalty</a:t>
+              <a:t>The gap shrinks for weaker credits (1.3× for CCC) — the risk premium is a smaller fraction of the total spread</a:t>
             </a:r>
           </a:p>
         </p:txBody>
@@ -19966,14 +19966,14 @@
         </p:nvSpPr>
         <p:spPr>
           <a:xfrm>
-            <a:off x="1371600" y="5669280"/>
-            <a:ext cx="6400800" cy="548640"/>
+            <a:off x="914400" y="5669280"/>
+            <a:ext cx="7315200" cy="548640"/>
           </a:xfrm>
           <a:prstGeom prst="roundRect">
             <a:avLst/>
           </a:prstGeom>
           <a:solidFill>
-            <a:srgbClr val="E04F4F"/>
+            <a:srgbClr val="E88D3F"/>
           </a:solidFill>
           <a:ln>
             <a:noFill/>
@@ -19998,7 +19998,7 @@
           <a:lstStyle/>
           <a:p>
             <a:pPr algn="ctr">
-              <a:defRPr sz="1300" b="1">
+              <a:defRPr sz="1200" b="1">
                 <a:solidFill>
                   <a:srgbClr val="FFFFFF"/>
                 </a:solidFill>
@@ -20006,7 +20006,7 @@
               </a:defRPr>
             </a:pPr>
             <a:r>
-              <a:t>A flat hazard-rate model gets the SIGN wrong for investment-grade PIK, and understates the dynamics for stressed credits.</a:t>
+              <a:t>Whether PIK benefits investors for strong credits depends on which default measure you use. Both models agree the effect is small (±60bp) for strong credits and large (100–260bp) for weak ones.</a:t>
             </a:r>
           </a:p>
         </p:txBody>

</xml_diff>

<commit_message>
refactor(covenants): reorganize Monte Carlo module structure and update imports
- Refactored the Monte Carlo module by moving components from `common_impl::mc` to `common_impl::models::monte_carlo`, enhancing clarity and organization.
- Updated import paths in `forward.rs` and `mod.rs` to reflect the new structure, ensuring consistency across the codebase.
- Removed the obsolete `mc` module and its associated files, streamlining the project structure.

This change improves the modularity and maintainability of the Monte Carlo simulation components, aligning with best practices in code organization.
</commit_message>
<xml_diff>
--- a/finstack-py/examples/scripts/valuations/instruments/pik_coupon_pricing.pptx
+++ b/finstack-py/examples/scripts/valuations/instruments/pik_coupon_pricing.pptx
@@ -11088,7 +11088,7 @@
                         </a:defRPr>
                       </a:pPr>
                       <a:r>
-                        <a:t>HR ΔPrice</a:t>
+                        <a:t>HR ΔZ (bp)</a:t>
                       </a:r>
                     </a:p>
                   </a:txBody>
@@ -11112,7 +11112,7 @@
                         </a:defRPr>
                       </a:pPr>
                       <a:r>
-                        <a:t>MC ΔPrice</a:t>
+                        <a:t>MC ΔZ (bp)</a:t>
                       </a:r>
                     </a:p>
                   </a:txBody>
@@ -11234,7 +11234,7 @@
                         </a:defRPr>
                       </a:pPr>
                       <a:r>
-                        <a:t>−2.5</a:t>
+                        <a:t>+40</a:t>
                       </a:r>
                     </a:p>
                   </a:txBody>
@@ -11258,7 +11258,7 @@
                         </a:defRPr>
                       </a:pPr>
                       <a:r>
-                        <a:t>+3.0</a:t>
+                        <a:t>−59</a:t>
                       </a:r>
                     </a:p>
                   </a:txBody>
@@ -11380,7 +11380,7 @@
                         </a:defRPr>
                       </a:pPr>
                       <a:r>
-                        <a:t>−3.8</a:t>
+                        <a:t>+60</a:t>
                       </a:r>
                     </a:p>
                   </a:txBody>
@@ -11404,7 +11404,7 @@
                         </a:defRPr>
                       </a:pPr>
                       <a:r>
-                        <a:t>+1.1</a:t>
+                        <a:t>−22</a:t>
                       </a:r>
                     </a:p>
                   </a:txBody>
@@ -11452,7 +11452,7 @@
                         </a:defRPr>
                       </a:pPr>
                       <a:r>
-                        <a:t>5.8%</a:t>
+                        <a:t>9.1%</a:t>
                       </a:r>
                     </a:p>
                   </a:txBody>
@@ -11476,7 +11476,7 @@
                         </a:defRPr>
                       </a:pPr>
                       <a:r>
-                        <a:t>2.7×</a:t>
+                        <a:t>1.7×</a:t>
                       </a:r>
                     </a:p>
                   </a:txBody>
@@ -11526,7 +11526,7 @@
                         </a:defRPr>
                       </a:pPr>
                       <a:r>
-                        <a:t>−5.3</a:t>
+                        <a:t>+91</a:t>
                       </a:r>
                     </a:p>
                   </a:txBody>
@@ -11550,7 +11550,7 @@
                         </a:defRPr>
                       </a:pPr>
                       <a:r>
-                        <a:t>−1.6</a:t>
+                        <a:t>+37</a:t>
                       </a:r>
                     </a:p>
                   </a:txBody>
@@ -11598,7 +11598,7 @@
                         </a:defRPr>
                       </a:pPr>
                       <a:r>
-                        <a:t>13.2%</a:t>
+                        <a:t>20.8%</a:t>
                       </a:r>
                     </a:p>
                   </a:txBody>
@@ -11622,7 +11622,7 @@
                         </a:defRPr>
                       </a:pPr>
                       <a:r>
-                        <a:t>1.9×</a:t>
+                        <a:t>1.2×</a:t>
                       </a:r>
                     </a:p>
                   </a:txBody>
@@ -11672,7 +11672,7 @@
                         </a:defRPr>
                       </a:pPr>
                       <a:r>
-                        <a:t>−6.9</a:t>
+                        <a:t>+137</a:t>
                       </a:r>
                     </a:p>
                   </a:txBody>
@@ -11696,7 +11696,7 @@
                         </a:defRPr>
                       </a:pPr>
                       <a:r>
-                        <a:t>−4.9</a:t>
+                        <a:t>+141</a:t>
                       </a:r>
                     </a:p>
                   </a:txBody>
@@ -11744,7 +11744,7 @@
                         </a:defRPr>
                       </a:pPr>
                       <a:r>
-                        <a:t>25.7%</a:t>
+                        <a:t>41.1%</a:t>
                       </a:r>
                     </a:p>
                   </a:txBody>
@@ -11768,7 +11768,7 @@
                         </a:defRPr>
                       </a:pPr>
                       <a:r>
-                        <a:t>1.4×</a:t>
+                        <a:t>0.9×</a:t>
                       </a:r>
                     </a:p>
                   </a:txBody>
@@ -11818,7 +11818,7 @@
                         </a:defRPr>
                       </a:pPr>
                       <a:r>
-                        <a:t>−8.8</a:t>
+                        <a:t>+224</a:t>
                       </a:r>
                     </a:p>
                   </a:txBody>
@@ -11842,7 +11842,7 @@
                         </a:defRPr>
                       </a:pPr>
                       <a:r>
-                        <a:t>−6.2</a:t>
+                        <a:t>+262</a:t>
                       </a:r>
                     </a:p>
                   </a:txBody>
@@ -11890,7 +11890,7 @@
                         </a:defRPr>
                       </a:pPr>
                       <a:r>
-                        <a:t>42.3%</a:t>
+                        <a:t>65.0%</a:t>
                       </a:r>
                     </a:p>
                   </a:txBody>
@@ -11914,7 +11914,7 @@
                         </a:defRPr>
                       </a:pPr>
                       <a:r>
-                        <a:t>1.2×</a:t>
+                        <a:t>0.8×</a:t>
                       </a:r>
                     </a:p>
                   </a:txBody>
@@ -11960,7 +11960,7 @@
               </a:defRPr>
             </a:pPr>
             <a:r>
-              <a:t>ΔPrice = PIK minus Cash (points). HR 5Y PD = market-implied. MC DefRate = simulation default rate.</a:t>
+              <a:t>ΔZ = PIK Z-spread minus Cash Z-spread (bp). HR 5Y PD = market-implied. MC DefRate = simulation default rate.</a:t>
             </a:r>
           </a:p>
         </p:txBody>
@@ -11999,7 +11999,7 @@
               </a:defRPr>
             </a:pPr>
             <a:r>
-              <a:t>The HR model uses market-implied defaults (including risk premium) → PIK always costs. The MC model uses historical PDs for barriers → fewer defaults → PIK compounding survives</a:t>
+              <a:t>For BB+: HR says PIK costs +40bp; MC says PIK saves −59bp. The sign reversal is driven by the 3.6× gap in default assumptions — fewer MC defaults means PIK compounding survives on ~98% of paths</a:t>
             </a:r>
           </a:p>
           <a:p>
@@ -12015,7 +12015,7 @@
               </a:defRPr>
             </a:pPr>
             <a:r>
-              <a:t>For BB+: the HR model sees 3.6× more defaults than the MC model. This gap drives the sign reversal in PIK pricing</a:t>
+              <a:t>For B−/CCC: both models agree PIK costs +137–262bp. MC even exceeds HR for CCC (+262 vs +224bp) because the feedback loop stacks on top of barrier crossings</a:t>
             </a:r>
           </a:p>
           <a:p>
@@ -12031,23 +12031,7 @@
               </a:defRPr>
             </a:pPr>
             <a:r>
-              <a:t>For CCC: both models see similar default rates (ratio 1.2×). The PIK penalty is robust regardless of calibration</a:t>
-            </a:r>
-          </a:p>
-          <a:p>
-            <a:pPr>
-              <a:spcAft>
-                <a:spcPts val="800"/>
-              </a:spcAft>
-              <a:defRPr sz="1300">
-                <a:solidFill>
-                  <a:srgbClr val="2D2D3D"/>
-                </a:solidFill>
-                <a:latin typeface="Calibri"/>
-              </a:defRPr>
-            </a:pPr>
-            <a:r>
-              <a:t>The practical implication: for strong credits, the PIK premium/discount is small either way (±60bp). For weak credits, it's large (+100–260bp) and model choice barely matters</a:t>
+              <a:t>Both models agree where it matters most: PIK penalty is large for B and below (+37 to +262bp), and small/model-dependent for BB+ and BB− (±60bp)</a:t>
             </a:r>
           </a:p>
         </p:txBody>
@@ -18150,7 +18134,7 @@
                         </a:defRPr>
                       </a:pPr>
                       <a:r>
-                        <a:t>Δ Price</a:t>
+                        <a:t>ΔZ (bp)</a:t>
                       </a:r>
                     </a:p>
                   </a:txBody>
@@ -18248,7 +18232,7 @@
                         </a:defRPr>
                       </a:pPr>
                       <a:r>
-                        <a:t>110.89</a:t>
+                        <a:t>111.46</a:t>
                       </a:r>
                     </a:p>
                   </a:txBody>
@@ -18272,7 +18256,7 @@
                         </a:defRPr>
                       </a:pPr>
                       <a:r>
-                        <a:t>−2.46</a:t>
+                        <a:t>+40</a:t>
                       </a:r>
                     </a:p>
                   </a:txBody>
@@ -18370,7 +18354,7 @@
                         </a:defRPr>
                       </a:pPr>
                       <a:r>
-                        <a:t>103.76</a:t>
+                        <a:t>104.88</a:t>
                       </a:r>
                     </a:p>
                   </a:txBody>
@@ -18394,7 +18378,7 @@
                         </a:defRPr>
                       </a:pPr>
                       <a:r>
-                        <a:t>−3.80</a:t>
+                        <a:t>+60</a:t>
                       </a:r>
                     </a:p>
                   </a:txBody>
@@ -18492,7 +18476,7 @@
                         </a:defRPr>
                       </a:pPr>
                       <a:r>
-                        <a:t>94.44</a:t>
+                        <a:t>96.05</a:t>
                       </a:r>
                     </a:p>
                   </a:txBody>
@@ -18516,7 +18500,7 @@
                         </a:defRPr>
                       </a:pPr>
                       <a:r>
-                        <a:t>−5.32</a:t>
+                        <a:t>+91</a:t>
                       </a:r>
                     </a:p>
                   </a:txBody>
@@ -18614,7 +18598,7 @@
                         </a:defRPr>
                       </a:pPr>
                       <a:r>
-                        <a:t>83.45</a:t>
+                        <a:t>85.40</a:t>
                       </a:r>
                     </a:p>
                   </a:txBody>
@@ -18638,7 +18622,7 @@
                         </a:defRPr>
                       </a:pPr>
                       <a:r>
-                        <a:t>−6.88</a:t>
+                        <a:t>+137</a:t>
                       </a:r>
                     </a:p>
                   </a:txBody>
@@ -18736,7 +18720,7 @@
                         </a:defRPr>
                       </a:pPr>
                       <a:r>
-                        <a:t>67.34</a:t>
+                        <a:t>69.59</a:t>
                       </a:r>
                     </a:p>
                   </a:txBody>
@@ -18760,7 +18744,7 @@
                         </a:defRPr>
                       </a:pPr>
                       <a:r>
-                        <a:t>−8.79</a:t>
+                        <a:t>+224</a:t>
                       </a:r>
                     </a:p>
                   </a:txBody>
@@ -18825,7 +18809,7 @@
               </a:defRPr>
             </a:pPr>
             <a:r>
-              <a:t>The gap widens with credit risk: from −2.5 pts (BB+) to −8.8 pts (CCC)</a:t>
+              <a:t>ΔZ = cash-equivalent Z-spread difference: PIK trades +40bp wider (BB+) to +224bp wider (CCC) than a cash-pay bond</a:t>
             </a:r>
           </a:p>
           <a:p>

</xml_diff>

<commit_message>
feat(trees): add mean reversion option to Hull-White tree model
- Introduced `mean_reversion` parameter to the `ModelConfig` struct, allowing for Hull-White dynamics in the short rate tree model.
- Updated the `TreePricer` configuration to accommodate the new mean reversion setting, enhancing the model's flexibility in capturing interest rate behaviors.
- Enhanced documentation to clarify the impact of mean reversion on rate dispersion and model dynamics.
- Added tests to validate the backward compatibility with existing configurations and ensure correct functionality with the new parameter.

This enhancement improves the modeling capabilities of the Hull-White tree, providing users with more control over interest rate dynamics.
</commit_message>
<xml_diff>
--- a/finstack-py/examples/scripts/valuations/instruments/pik_coupon_pricing.pptx
+++ b/finstack-py/examples/scripts/valuations/instruments/pik_coupon_pricing.pptx
@@ -3658,7 +3658,7 @@
               </a:defRPr>
             </a:pPr>
             <a:r>
-              <a:t>For strong credits (BB+): PIK premium is small (±60bp) and sign is model-dependent</a:t>
+              <a:t>For strong credits (BB+, 2.0× coverage): PIK premium is small (±60bp) and sign is model-dependent</a:t>
             </a:r>
           </a:p>
           <a:p>
@@ -3674,7 +3674,7 @@
               </a:defRPr>
             </a:pPr>
             <a:r>
-              <a:t>For stressed credits (CCC): PIK premium &gt; +260bp, robust across models</a:t>
+              <a:t>For stressed credits (CCC, 1.15× coverage): PIK premium &gt; +260bp, robust across models</a:t>
             </a:r>
           </a:p>
           <a:p>
@@ -3945,7 +3945,7 @@
         </p:nvGraphicFramePr>
         <p:xfrm>
           <a:off x="457200" y="1005840"/>
-          <a:ext cx="5029200" cy="1920239"/>
+          <a:ext cx="4937760" cy="1920239"/>
         </p:xfrm>
         <a:graphic>
           <a:graphicData uri="http://schemas.openxmlformats.org/drawingml/2006/table">
@@ -3954,11 +3954,12 @@
                 <a:tableStyleId>{5C22544A-7EE6-4342-B048-85BDC9FD1C3A}</a:tableStyleId>
               </a:tblPr>
               <a:tblGrid>
-                <a:gridCol w="1645920"/>
+                <a:gridCol w="1371600"/>
+                <a:gridCol w="457200"/>
                 <a:gridCol w="640080"/>
-                <a:gridCol w="914400"/>
-                <a:gridCol w="914400"/>
-                <a:gridCol w="914400"/>
+                <a:gridCol w="822960"/>
+                <a:gridCol w="822960"/>
+                <a:gridCol w="822960"/>
               </a:tblGrid>
               <a:tr h="320039">
                 <a:tc>
@@ -3999,7 +4000,7 @@
                         </a:defRPr>
                       </a:pPr>
                       <a:r>
-                        <a:t>λ (bp)</a:t>
+                        <a:t>LTV</a:t>
                       </a:r>
                     </a:p>
                   </a:txBody>
@@ -4023,7 +4024,7 @@
                         </a:defRPr>
                       </a:pPr>
                       <a:r>
-                        <a:t>Cash Price</a:t>
+                        <a:t>λ (bp)</a:t>
                       </a:r>
                     </a:p>
                   </a:txBody>
@@ -4047,7 +4048,7 @@
                         </a:defRPr>
                       </a:pPr>
                       <a:r>
-                        <a:t>PIK Price</a:t>
+                        <a:t>Cash Price</a:t>
                       </a:r>
                     </a:p>
                   </a:txBody>
@@ -4071,6 +4072,30 @@
                         </a:defRPr>
                       </a:pPr>
                       <a:r>
+                        <a:t>PIK Price</a:t>
+                      </a:r>
+                    </a:p>
+                  </a:txBody>
+                  <a:tcPr>
+                    <a:solidFill>
+                      <a:srgbClr val="2C3E6B"/>
+                    </a:solidFill>
+                  </a:tcPr>
+                </a:tc>
+                <a:tc>
+                  <a:txBody>
+                    <a:bodyPr/>
+                    <a:lstStyle/>
+                    <a:p>
+                      <a:pPr algn="ctr">
+                        <a:defRPr sz="1100" b="1">
+                          <a:solidFill>
+                            <a:srgbClr val="FFFFFF"/>
+                          </a:solidFill>
+                          <a:latin typeface="Calibri"/>
+                        </a:defRPr>
+                      </a:pPr>
+                      <a:r>
                         <a:t>ΔZ (bp)</a:t>
                       </a:r>
                     </a:p>
@@ -4121,7 +4146,7 @@
                         </a:defRPr>
                       </a:pPr>
                       <a:r>
-                        <a:t>143</a:t>
+                        <a:t>50%</a:t>
                       </a:r>
                     </a:p>
                   </a:txBody>
@@ -4145,7 +4170,7 @@
                         </a:defRPr>
                       </a:pPr>
                       <a:r>
-                        <a:t>113.35</a:t>
+                        <a:t>143</a:t>
                       </a:r>
                     </a:p>
                   </a:txBody>
@@ -4169,7 +4194,7 @@
                         </a:defRPr>
                       </a:pPr>
                       <a:r>
-                        <a:t>111.46</a:t>
+                        <a:t>113.35</a:t>
                       </a:r>
                     </a:p>
                   </a:txBody>
@@ -4193,6 +4218,30 @@
                         </a:defRPr>
                       </a:pPr>
                       <a:r>
+                        <a:t>111.46</a:t>
+                      </a:r>
+                    </a:p>
+                  </a:txBody>
+                  <a:tcPr>
+                    <a:solidFill>
+                      <a:srgbClr val="FFFFFF"/>
+                    </a:solidFill>
+                  </a:tcPr>
+                </a:tc>
+                <a:tc>
+                  <a:txBody>
+                    <a:bodyPr/>
+                    <a:lstStyle/>
+                    <a:p>
+                      <a:pPr algn="r">
+                        <a:defRPr sz="1100">
+                          <a:solidFill>
+                            <a:srgbClr val="2D2D3D"/>
+                          </a:solidFill>
+                          <a:latin typeface="Calibri"/>
+                        </a:defRPr>
+                      </a:pPr>
+                      <a:r>
                         <a:t>+40</a:t>
                       </a:r>
                     </a:p>
@@ -4243,7 +4292,7 @@
                         </a:defRPr>
                       </a:pPr>
                       <a:r>
-                        <a:t>334</a:t>
+                        <a:t>61%</a:t>
                       </a:r>
                     </a:p>
                   </a:txBody>
@@ -4267,7 +4316,7 @@
                         </a:defRPr>
                       </a:pPr>
                       <a:r>
-                        <a:t>107.56</a:t>
+                        <a:t>334</a:t>
                       </a:r>
                     </a:p>
                   </a:txBody>
@@ -4291,7 +4340,7 @@
                         </a:defRPr>
                       </a:pPr>
                       <a:r>
-                        <a:t>104.88</a:t>
+                        <a:t>107.56</a:t>
                       </a:r>
                     </a:p>
                   </a:txBody>
@@ -4315,6 +4364,30 @@
                         </a:defRPr>
                       </a:pPr>
                       <a:r>
+                        <a:t>104.88</a:t>
+                      </a:r>
+                    </a:p>
+                  </a:txBody>
+                  <a:tcPr>
+                    <a:solidFill>
+                      <a:srgbClr val="E8EBF5"/>
+                    </a:solidFill>
+                  </a:tcPr>
+                </a:tc>
+                <a:tc>
+                  <a:txBody>
+                    <a:bodyPr/>
+                    <a:lstStyle/>
+                    <a:p>
+                      <a:pPr algn="r">
+                        <a:defRPr sz="1100">
+                          <a:solidFill>
+                            <a:srgbClr val="2D2D3D"/>
+                          </a:solidFill>
+                          <a:latin typeface="Calibri"/>
+                        </a:defRPr>
+                      </a:pPr>
+                      <a:r>
                         <a:t>+60</a:t>
                       </a:r>
                     </a:p>
@@ -4365,7 +4438,7 @@
                         </a:defRPr>
                       </a:pPr>
                       <a:r>
-                        <a:t>591</a:t>
+                        <a:t>71%</a:t>
                       </a:r>
                     </a:p>
                   </a:txBody>
@@ -4389,7 +4462,7 @@
                         </a:defRPr>
                       </a:pPr>
                       <a:r>
-                        <a:t>99.76</a:t>
+                        <a:t>591</a:t>
                       </a:r>
                     </a:p>
                   </a:txBody>
@@ -4413,7 +4486,7 @@
                         </a:defRPr>
                       </a:pPr>
                       <a:r>
-                        <a:t>96.05</a:t>
+                        <a:t>99.76</a:t>
                       </a:r>
                     </a:p>
                   </a:txBody>
@@ -4437,6 +4510,30 @@
                         </a:defRPr>
                       </a:pPr>
                       <a:r>
+                        <a:t>96.05</a:t>
+                      </a:r>
+                    </a:p>
+                  </a:txBody>
+                  <a:tcPr>
+                    <a:solidFill>
+                      <a:srgbClr val="FFFFFF"/>
+                    </a:solidFill>
+                  </a:tcPr>
+                </a:tc>
+                <a:tc>
+                  <a:txBody>
+                    <a:bodyPr/>
+                    <a:lstStyle/>
+                    <a:p>
+                      <a:pPr algn="r">
+                        <a:defRPr sz="1100">
+                          <a:solidFill>
+                            <a:srgbClr val="2D2D3D"/>
+                          </a:solidFill>
+                          <a:latin typeface="Calibri"/>
+                        </a:defRPr>
+                      </a:pPr>
+                      <a:r>
                         <a:t>+91</a:t>
                       </a:r>
                     </a:p>
@@ -4487,7 +4584,7 @@
                         </a:defRPr>
                       </a:pPr>
                       <a:r>
-                        <a:t>911</a:t>
+                        <a:t>80%</a:t>
                       </a:r>
                     </a:p>
                   </a:txBody>
@@ -4511,7 +4608,7 @@
                         </a:defRPr>
                       </a:pPr>
                       <a:r>
-                        <a:t>90.33</a:t>
+                        <a:t>911</a:t>
                       </a:r>
                     </a:p>
                   </a:txBody>
@@ -4535,7 +4632,7 @@
                         </a:defRPr>
                       </a:pPr>
                       <a:r>
-                        <a:t>85.40</a:t>
+                        <a:t>90.33</a:t>
                       </a:r>
                     </a:p>
                   </a:txBody>
@@ -4559,6 +4656,30 @@
                         </a:defRPr>
                       </a:pPr>
                       <a:r>
+                        <a:t>85.40</a:t>
+                      </a:r>
+                    </a:p>
+                  </a:txBody>
+                  <a:tcPr>
+                    <a:solidFill>
+                      <a:srgbClr val="E8EBF5"/>
+                    </a:solidFill>
+                  </a:tcPr>
+                </a:tc>
+                <a:tc>
+                  <a:txBody>
+                    <a:bodyPr/>
+                    <a:lstStyle/>
+                    <a:p>
+                      <a:pPr algn="r">
+                        <a:defRPr sz="1100">
+                          <a:solidFill>
+                            <a:srgbClr val="2D2D3D"/>
+                          </a:solidFill>
+                          <a:latin typeface="Calibri"/>
+                        </a:defRPr>
+                      </a:pPr>
+                      <a:r>
                         <a:t>+137</a:t>
                       </a:r>
                     </a:p>
@@ -4586,6 +4707,30 @@
                       </a:pPr>
                       <a:r>
                         <a:t>CCC (Deeply Stressed)</a:t>
+                      </a:r>
+                    </a:p>
+                  </a:txBody>
+                  <a:tcPr>
+                    <a:solidFill>
+                      <a:srgbClr val="FFFFFF"/>
+                    </a:solidFill>
+                  </a:tcPr>
+                </a:tc>
+                <a:tc>
+                  <a:txBody>
+                    <a:bodyPr/>
+                    <a:lstStyle/>
+                    <a:p>
+                      <a:pPr algn="r">
+                        <a:defRPr sz="1100">
+                          <a:solidFill>
+                            <a:srgbClr val="2D2D3D"/>
+                          </a:solidFill>
+                          <a:latin typeface="Calibri"/>
+                        </a:defRPr>
+                      </a:pPr>
+                      <a:r>
+                        <a:t>87%</a:t>
                       </a:r>
                     </a:p>
                   </a:txBody>
@@ -4751,10 +4896,11 @@
                 <a:tableStyleId>{5C22544A-7EE6-4342-B048-85BDC9FD1C3A}</a:tableStyleId>
               </a:tblPr>
               <a:tblGrid>
-                <a:gridCol w="640080"/>
-                <a:gridCol w="822960"/>
-                <a:gridCol w="822960"/>
-                <a:gridCol w="640080"/>
+                <a:gridCol w="457200"/>
+                <a:gridCol w="457200"/>
+                <a:gridCol w="731520"/>
+                <a:gridCol w="731520"/>
+                <a:gridCol w="548640"/>
               </a:tblGrid>
               <a:tr h="320040">
                 <a:tc>
@@ -4795,7 +4941,7 @@
                         </a:defRPr>
                       </a:pPr>
                       <a:r>
-                        <a:t>HR 5Y PD</a:t>
+                        <a:t>LTV</a:t>
                       </a:r>
                     </a:p>
                   </a:txBody>
@@ -4819,7 +4965,7 @@
                         </a:defRPr>
                       </a:pPr>
                       <a:r>
-                        <a:t>Hist 5Y PD</a:t>
+                        <a:t>HR 5Y PD</a:t>
                       </a:r>
                     </a:p>
                   </a:txBody>
@@ -4843,6 +4989,30 @@
                         </a:defRPr>
                       </a:pPr>
                       <a:r>
+                        <a:t>Hist 5Y PD</a:t>
+                      </a:r>
+                    </a:p>
+                  </a:txBody>
+                  <a:tcPr>
+                    <a:solidFill>
+                      <a:srgbClr val="2C3E6B"/>
+                    </a:solidFill>
+                  </a:tcPr>
+                </a:tc>
+                <a:tc>
+                  <a:txBody>
+                    <a:bodyPr/>
+                    <a:lstStyle/>
+                    <a:p>
+                      <a:pPr algn="ctr">
+                        <a:defRPr sz="1000" b="1">
+                          <a:solidFill>
+                            <a:srgbClr val="FFFFFF"/>
+                          </a:solidFill>
+                          <a:latin typeface="Calibri"/>
+                        </a:defRPr>
+                      </a:pPr>
+                      <a:r>
                         <a:t>Ratio</a:t>
                       </a:r>
                     </a:p>
@@ -4893,7 +5063,7 @@
                         </a:defRPr>
                       </a:pPr>
                       <a:r>
-                        <a:t>6.9%</a:t>
+                        <a:t>50%</a:t>
                       </a:r>
                     </a:p>
                   </a:txBody>
@@ -4917,7 +5087,7 @@
                         </a:defRPr>
                       </a:pPr>
                       <a:r>
-                        <a:t>1.0%</a:t>
+                        <a:t>6.9%</a:t>
                       </a:r>
                     </a:p>
                   </a:txBody>
@@ -4941,6 +5111,30 @@
                         </a:defRPr>
                       </a:pPr>
                       <a:r>
+                        <a:t>1.0%</a:t>
+                      </a:r>
+                    </a:p>
+                  </a:txBody>
+                  <a:tcPr>
+                    <a:solidFill>
+                      <a:srgbClr val="FFFFFF"/>
+                    </a:solidFill>
+                  </a:tcPr>
+                </a:tc>
+                <a:tc>
+                  <a:txBody>
+                    <a:bodyPr/>
+                    <a:lstStyle/>
+                    <a:p>
+                      <a:pPr algn="r">
+                        <a:defRPr sz="1000">
+                          <a:solidFill>
+                            <a:srgbClr val="2D2D3D"/>
+                          </a:solidFill>
+                          <a:latin typeface="Calibri"/>
+                        </a:defRPr>
+                      </a:pPr>
+                      <a:r>
                         <a:t>6.9×</a:t>
                       </a:r>
                     </a:p>
@@ -4991,7 +5185,7 @@
                         </a:defRPr>
                       </a:pPr>
                       <a:r>
-                        <a:t>25.6%</a:t>
+                        <a:t>71%</a:t>
                       </a:r>
                     </a:p>
                   </a:txBody>
@@ -5015,7 +5209,7 @@
                         </a:defRPr>
                       </a:pPr>
                       <a:r>
-                        <a:t>11.8%</a:t>
+                        <a:t>25.6%</a:t>
                       </a:r>
                     </a:p>
                   </a:txBody>
@@ -5039,6 +5233,30 @@
                         </a:defRPr>
                       </a:pPr>
                       <a:r>
+                        <a:t>11.8%</a:t>
+                      </a:r>
+                    </a:p>
+                  </a:txBody>
+                  <a:tcPr>
+                    <a:solidFill>
+                      <a:srgbClr val="E8EBF5"/>
+                    </a:solidFill>
+                  </a:tcPr>
+                </a:tc>
+                <a:tc>
+                  <a:txBody>
+                    <a:bodyPr/>
+                    <a:lstStyle/>
+                    <a:p>
+                      <a:pPr algn="r">
+                        <a:defRPr sz="1000">
+                          <a:solidFill>
+                            <a:srgbClr val="2D2D3D"/>
+                          </a:solidFill>
+                          <a:latin typeface="Calibri"/>
+                        </a:defRPr>
+                      </a:pPr>
+                      <a:r>
                         <a:t>2.2×</a:t>
                       </a:r>
                     </a:p>
@@ -5066,6 +5284,30 @@
                       </a:pPr>
                       <a:r>
                         <a:t>CCC</a:t>
+                      </a:r>
+                    </a:p>
+                  </a:txBody>
+                  <a:tcPr>
+                    <a:solidFill>
+                      <a:srgbClr val="FFFFFF"/>
+                    </a:solidFill>
+                  </a:tcPr>
+                </a:tc>
+                <a:tc>
+                  <a:txBody>
+                    <a:bodyPr/>
+                    <a:lstStyle/>
+                    <a:p>
+                      <a:pPr algn="r">
+                        <a:defRPr sz="1000">
+                          <a:solidFill>
+                            <a:srgbClr val="2D2D3D"/>
+                          </a:solidFill>
+                          <a:latin typeface="Calibri"/>
+                        </a:defRPr>
+                      </a:pPr>
+                      <a:r>
+                        <a:t>87%</a:t>
                       </a:r>
                     </a:p>
                   </a:txBody>
@@ -5160,7 +5402,43 @@
         </p:nvSpPr>
         <p:spPr>
           <a:xfrm>
-            <a:off x="457200" y="3474720"/>
+            <a:off x="457200" y="3246120"/>
+            <a:ext cx="5029200" cy="228600"/>
+          </a:xfrm>
+          <a:prstGeom prst="rect">
+            <a:avLst/>
+          </a:prstGeom>
+          <a:noFill/>
+        </p:spPr>
+        <p:txBody>
+          <a:bodyPr wrap="square">
+            <a:spAutoFit/>
+          </a:bodyPr>
+          <a:lstStyle/>
+          <a:p>
+            <a:pPr algn="l">
+              <a:defRPr sz="900" b="0">
+                <a:solidFill>
+                  <a:srgbClr val="555570"/>
+                </a:solidFill>
+                <a:latin typeface="Calibri"/>
+              </a:defRPr>
+            </a:pPr>
+            <a:r>
+              <a:t>LTV = Debt / Enterprise Value at origination</a:t>
+            </a:r>
+          </a:p>
+        </p:txBody>
+      </p:sp>
+      <p:sp>
+        <p:nvSpPr>
+          <p:cNvPr id="10" name="TextBox 9"/>
+          <p:cNvSpPr txBox="1"/>
+          <p:nvPr/>
+        </p:nvSpPr>
+        <p:spPr>
+          <a:xfrm>
+            <a:off x="457200" y="3566160"/>
             <a:ext cx="8229600" cy="1371600"/>
           </a:xfrm>
           <a:prstGeom prst="rect">
@@ -5186,7 +5464,7 @@
               </a:defRPr>
             </a:pPr>
             <a:r>
-              <a:t>Under risk-neutral hazard rates, PIK always trades wider: +40bp (BB+) to +224bp (CCC). The concentrated maturity exposure penalises PIK at every credit level</a:t>
+              <a:t>Under risk-neutral hazard rates, PIK always trades wider: +40bp at 50% LTV (BB+) to +224bp at 87% LTV (CCC). Concentrated maturity exposure penalises PIK at every level</a:t>
             </a:r>
           </a:p>
           <a:p>
@@ -5202,20 +5480,20 @@
               </a:defRPr>
             </a:pPr>
             <a:r>
-              <a:t>But market spreads embed a risk premium above expected losses. For BB+ the spread implies 7× the historical default rate — the PIK penalty may be overstated for strong credits</a:t>
-            </a:r>
-          </a:p>
-        </p:txBody>
-      </p:sp>
-      <p:sp>
-        <p:nvSpPr>
-          <p:cNvPr id="10" name="Rounded Rectangle 9"/>
+              <a:t>But market spreads embed a risk premium above expected losses. At 50% LTV the spread implies 7× the historical default rate — the PIK penalty may be overstated for low-LTV credits</a:t>
+            </a:r>
+          </a:p>
+        </p:txBody>
+      </p:sp>
+      <p:sp>
+        <p:nvSpPr>
+          <p:cNvPr id="11" name="Rounded Rectangle 10"/>
           <p:cNvSpPr/>
           <p:nvPr/>
         </p:nvSpPr>
         <p:spPr>
           <a:xfrm>
-            <a:off x="914400" y="5029200"/>
+            <a:off x="914400" y="5120640"/>
             <a:ext cx="7315200" cy="594360"/>
           </a:xfrm>
           <a:prstGeom prst="roundRect">
@@ -6009,7 +6287,7 @@
         </p:nvGraphicFramePr>
         <p:xfrm>
           <a:off x="457200" y="2788920"/>
-          <a:ext cx="7223760" cy="1920239"/>
+          <a:ext cx="6858000" cy="1920239"/>
         </p:xfrm>
         <a:graphic>
           <a:graphicData uri="http://schemas.openxmlformats.org/drawingml/2006/table">
@@ -6018,12 +6296,13 @@
                 <a:tableStyleId>{5C22544A-7EE6-4342-B048-85BDC9FD1C3A}</a:tableStyleId>
               </a:tblPr>
               <a:tblGrid>
-                <a:gridCol w="2011680"/>
+                <a:gridCol w="1645920"/>
+                <a:gridCol w="457200"/>
+                <a:gridCol w="914400"/>
+                <a:gridCol w="914400"/>
+                <a:gridCol w="914400"/>
                 <a:gridCol w="1005840"/>
                 <a:gridCol w="1005840"/>
-                <a:gridCol w="1005840"/>
-                <a:gridCol w="1097280"/>
-                <a:gridCol w="1097280"/>
               </a:tblGrid>
               <a:tr h="320039">
                 <a:tc>
@@ -6064,7 +6343,7 @@
                         </a:defRPr>
                       </a:pPr>
                       <a:r>
-                        <a:t>Cash</a:t>
+                        <a:t>LTV</a:t>
                       </a:r>
                     </a:p>
                   </a:txBody>
@@ -6088,7 +6367,7 @@
                         </a:defRPr>
                       </a:pPr>
                       <a:r>
-                        <a:t>PIK</a:t>
+                        <a:t>Cash</a:t>
                       </a:r>
                     </a:p>
                   </a:txBody>
@@ -6112,7 +6391,7 @@
                         </a:defRPr>
                       </a:pPr>
                       <a:r>
-                        <a:t>Toggle</a:t>
+                        <a:t>PIK</a:t>
                       </a:r>
                     </a:p>
                   </a:txBody>
@@ -6136,7 +6415,7 @@
                         </a:defRPr>
                       </a:pPr>
                       <a:r>
-                        <a:t>PIK−Cash</a:t>
+                        <a:t>Toggle</a:t>
                       </a:r>
                     </a:p>
                   </a:txBody>
@@ -6160,6 +6439,30 @@
                         </a:defRPr>
                       </a:pPr>
                       <a:r>
+                        <a:t>PIK−Cash</a:t>
+                      </a:r>
+                    </a:p>
+                  </a:txBody>
+                  <a:tcPr>
+                    <a:solidFill>
+                      <a:srgbClr val="2C3E6B"/>
+                    </a:solidFill>
+                  </a:tcPr>
+                </a:tc>
+                <a:tc>
+                  <a:txBody>
+                    <a:bodyPr/>
+                    <a:lstStyle/>
+                    <a:p>
+                      <a:pPr algn="ctr">
+                        <a:defRPr sz="1100" b="1">
+                          <a:solidFill>
+                            <a:srgbClr val="FFFFFF"/>
+                          </a:solidFill>
+                          <a:latin typeface="Calibri"/>
+                        </a:defRPr>
+                      </a:pPr>
+                      <a:r>
                         <a:t>Tog−Cash</a:t>
                       </a:r>
                     </a:p>
@@ -6210,7 +6513,7 @@
                         </a:defRPr>
                       </a:pPr>
                       <a:r>
-                        <a:t>20bp</a:t>
+                        <a:t>50%</a:t>
                       </a:r>
                     </a:p>
                   </a:txBody>
@@ -6234,7 +6537,7 @@
                         </a:defRPr>
                       </a:pPr>
                       <a:r>
-                        <a:t>−39bp</a:t>
+                        <a:t>20bp</a:t>
                       </a:r>
                     </a:p>
                   </a:txBody>
@@ -6258,7 +6561,7 @@
                         </a:defRPr>
                       </a:pPr>
                       <a:r>
-                        <a:t>22bp</a:t>
+                        <a:t>−39bp</a:t>
                       </a:r>
                     </a:p>
                   </a:txBody>
@@ -6282,7 +6585,7 @@
                         </a:defRPr>
                       </a:pPr>
                       <a:r>
-                        <a:t>−59</a:t>
+                        <a:t>22bp</a:t>
                       </a:r>
                     </a:p>
                   </a:txBody>
@@ -6306,6 +6609,30 @@
                         </a:defRPr>
                       </a:pPr>
                       <a:r>
+                        <a:t>−59</a:t>
+                      </a:r>
+                    </a:p>
+                  </a:txBody>
+                  <a:tcPr>
+                    <a:solidFill>
+                      <a:srgbClr val="FFFFFF"/>
+                    </a:solidFill>
+                  </a:tcPr>
+                </a:tc>
+                <a:tc>
+                  <a:txBody>
+                    <a:bodyPr/>
+                    <a:lstStyle/>
+                    <a:p>
+                      <a:pPr algn="r">
+                        <a:defRPr sz="1100">
+                          <a:solidFill>
+                            <a:srgbClr val="2D2D3D"/>
+                          </a:solidFill>
+                          <a:latin typeface="Calibri"/>
+                        </a:defRPr>
+                      </a:pPr>
+                      <a:r>
                         <a:t>+1</a:t>
                       </a:r>
                     </a:p>
@@ -6356,7 +6683,7 @@
                         </a:defRPr>
                       </a:pPr>
                       <a:r>
-                        <a:t>110bp</a:t>
+                        <a:t>61%</a:t>
                       </a:r>
                     </a:p>
                   </a:txBody>
@@ -6380,7 +6707,7 @@
                         </a:defRPr>
                       </a:pPr>
                       <a:r>
-                        <a:t>88bp</a:t>
+                        <a:t>110bp</a:t>
                       </a:r>
                     </a:p>
                   </a:txBody>
@@ -6404,7 +6731,7 @@
                         </a:defRPr>
                       </a:pPr>
                       <a:r>
-                        <a:t>130bp</a:t>
+                        <a:t>88bp</a:t>
                       </a:r>
                     </a:p>
                   </a:txBody>
@@ -6428,7 +6755,7 @@
                         </a:defRPr>
                       </a:pPr>
                       <a:r>
-                        <a:t>−22</a:t>
+                        <a:t>130bp</a:t>
                       </a:r>
                     </a:p>
                   </a:txBody>
@@ -6452,6 +6779,30 @@
                         </a:defRPr>
                       </a:pPr>
                       <a:r>
+                        <a:t>−22</a:t>
+                      </a:r>
+                    </a:p>
+                  </a:txBody>
+                  <a:tcPr>
+                    <a:solidFill>
+                      <a:srgbClr val="E8EBF5"/>
+                    </a:solidFill>
+                  </a:tcPr>
+                </a:tc>
+                <a:tc>
+                  <a:txBody>
+                    <a:bodyPr/>
+                    <a:lstStyle/>
+                    <a:p>
+                      <a:pPr algn="r">
+                        <a:defRPr sz="1100">
+                          <a:solidFill>
+                            <a:srgbClr val="2D2D3D"/>
+                          </a:solidFill>
+                          <a:latin typeface="Calibri"/>
+                        </a:defRPr>
+                      </a:pPr>
+                      <a:r>
                         <a:t>+20</a:t>
                       </a:r>
                     </a:p>
@@ -6502,7 +6853,7 @@
                         </a:defRPr>
                       </a:pPr>
                       <a:r>
-                        <a:t>292bp</a:t>
+                        <a:t>71%</a:t>
                       </a:r>
                     </a:p>
                   </a:txBody>
@@ -6526,7 +6877,7 @@
                         </a:defRPr>
                       </a:pPr>
                       <a:r>
-                        <a:t>329bp</a:t>
+                        <a:t>292bp</a:t>
                       </a:r>
                     </a:p>
                   </a:txBody>
@@ -6550,7 +6901,7 @@
                         </a:defRPr>
                       </a:pPr>
                       <a:r>
-                        <a:t>346bp</a:t>
+                        <a:t>329bp</a:t>
                       </a:r>
                     </a:p>
                   </a:txBody>
@@ -6574,7 +6925,7 @@
                         </a:defRPr>
                       </a:pPr>
                       <a:r>
-                        <a:t>+37</a:t>
+                        <a:t>346bp</a:t>
                       </a:r>
                     </a:p>
                   </a:txBody>
@@ -6598,6 +6949,30 @@
                         </a:defRPr>
                       </a:pPr>
                       <a:r>
+                        <a:t>+37</a:t>
+                      </a:r>
+                    </a:p>
+                  </a:txBody>
+                  <a:tcPr>
+                    <a:solidFill>
+                      <a:srgbClr val="FFFFFF"/>
+                    </a:solidFill>
+                  </a:tcPr>
+                </a:tc>
+                <a:tc>
+                  <a:txBody>
+                    <a:bodyPr/>
+                    <a:lstStyle/>
+                    <a:p>
+                      <a:pPr algn="r">
+                        <a:defRPr sz="1100">
+                          <a:solidFill>
+                            <a:srgbClr val="2D2D3D"/>
+                          </a:solidFill>
+                          <a:latin typeface="Calibri"/>
+                        </a:defRPr>
+                      </a:pPr>
+                      <a:r>
                         <a:t>+54</a:t>
                       </a:r>
                     </a:p>
@@ -6648,7 +7023,7 @@
                         </a:defRPr>
                       </a:pPr>
                       <a:r>
-                        <a:t>710bp</a:t>
+                        <a:t>80%</a:t>
                       </a:r>
                     </a:p>
                   </a:txBody>
@@ -6672,7 +7047,7 @@
                         </a:defRPr>
                       </a:pPr>
                       <a:r>
-                        <a:t>851bp</a:t>
+                        <a:t>710bp</a:t>
                       </a:r>
                     </a:p>
                   </a:txBody>
@@ -6696,7 +7071,7 @@
                         </a:defRPr>
                       </a:pPr>
                       <a:r>
-                        <a:t>862bp</a:t>
+                        <a:t>851bp</a:t>
                       </a:r>
                     </a:p>
                   </a:txBody>
@@ -6720,7 +7095,7 @@
                         </a:defRPr>
                       </a:pPr>
                       <a:r>
-                        <a:t>+141</a:t>
+                        <a:t>862bp</a:t>
                       </a:r>
                     </a:p>
                   </a:txBody>
@@ -6744,6 +7119,30 @@
                         </a:defRPr>
                       </a:pPr>
                       <a:r>
+                        <a:t>+141</a:t>
+                      </a:r>
+                    </a:p>
+                  </a:txBody>
+                  <a:tcPr>
+                    <a:solidFill>
+                      <a:srgbClr val="E8EBF5"/>
+                    </a:solidFill>
+                  </a:tcPr>
+                </a:tc>
+                <a:tc>
+                  <a:txBody>
+                    <a:bodyPr/>
+                    <a:lstStyle/>
+                    <a:p>
+                      <a:pPr algn="r">
+                        <a:defRPr sz="1100">
+                          <a:solidFill>
+                            <a:srgbClr val="2D2D3D"/>
+                          </a:solidFill>
+                          <a:latin typeface="Calibri"/>
+                        </a:defRPr>
+                      </a:pPr>
+                      <a:r>
                         <a:t>+151</a:t>
                       </a:r>
                     </a:p>
@@ -6771,6 +7170,30 @@
                       </a:pPr>
                       <a:r>
                         <a:t>CCC (Deeply Stressed)</a:t>
+                      </a:r>
+                    </a:p>
+                  </a:txBody>
+                  <a:tcPr>
+                    <a:solidFill>
+                      <a:srgbClr val="FFFFFF"/>
+                    </a:solidFill>
+                  </a:tcPr>
+                </a:tc>
+                <a:tc>
+                  <a:txBody>
+                    <a:bodyPr/>
+                    <a:lstStyle/>
+                    <a:p>
+                      <a:pPr algn="r">
+                        <a:defRPr sz="1100">
+                          <a:solidFill>
+                            <a:srgbClr val="2D2D3D"/>
+                          </a:solidFill>
+                          <a:latin typeface="Calibri"/>
+                        </a:defRPr>
+                      </a:pPr>
+                      <a:r>
+                        <a:t>87%</a:t>
                       </a:r>
                     </a:p>
                   </a:txBody>
@@ -6939,7 +7362,7 @@
               </a:defRPr>
             </a:pPr>
             <a:r>
-              <a:t>BB+/BB−: MC shows PIK tighter (−59/−22bp) — under historical PDs, PIK compounding survives on ~98% of paths</a:t>
+              <a:t>At 50–61% LTV: MC shows PIK tighter (−59/−22bp) — under historical PDs, PIK compounding survives on ~98% of paths</a:t>
             </a:r>
           </a:p>
           <a:p>
@@ -6955,7 +7378,7 @@
               </a:defRPr>
             </a:pPr>
             <a:r>
-              <a:t>B− to CCC: PIK premium +141 to +262bp — the feedback loop dominates and both models agree</a:t>
+              <a:t>At 80–87% LTV: PIK premium +141 to +262bp — the feedback loop dominates and both models agree</a:t>
             </a:r>
           </a:p>
         </p:txBody>
@@ -9193,7 +9616,7 @@
               </a:defRPr>
             </a:pPr>
             <a:r>
-              <a:t>Mkt spread &lt; 300bp</a:t>
+              <a:t>LTV &lt; 65%  |  Mkt spread &lt; 300bp</a:t>
             </a:r>
             <a:br/>
             <a:r>
@@ -9286,7 +9709,7 @@
               </a:defRPr>
             </a:pPr>
             <a:r>
-              <a:t>300–500bp market spread</a:t>
+              <a:t>LTV 65–75%  |  300–500bp spread</a:t>
             </a:r>
             <a:br/>
             <a:r>
@@ -9379,7 +9802,7 @@
               </a:defRPr>
             </a:pPr>
             <a:r>
-              <a:t>Mkt spread &gt; 500bp</a:t>
+              <a:t>LTV &gt; 75%  |  Mkt spread &gt; 500bp</a:t>
             </a:r>
             <a:br/>
             <a:r>
@@ -9450,7 +9873,7 @@
                         </a:defRPr>
                       </a:pPr>
                       <a:r>
-                        <a:t>BB+</a:t>
+                        <a:t>BB+ (50%)</a:t>
                       </a:r>
                     </a:p>
                   </a:txBody>
@@ -9474,7 +9897,7 @@
                         </a:defRPr>
                       </a:pPr>
                       <a:r>
-                        <a:t>BB−</a:t>
+                        <a:t>BB− (61%)</a:t>
                       </a:r>
                     </a:p>
                   </a:txBody>
@@ -9498,7 +9921,7 @@
                         </a:defRPr>
                       </a:pPr>
                       <a:r>
-                        <a:t>B</a:t>
+                        <a:t>B (71%)</a:t>
                       </a:r>
                     </a:p>
                   </a:txBody>
@@ -9522,7 +9945,7 @@
                         </a:defRPr>
                       </a:pPr>
                       <a:r>
-                        <a:t>B−</a:t>
+                        <a:t>B− (80%)</a:t>
                       </a:r>
                     </a:p>
                   </a:txBody>
@@ -9546,7 +9969,7 @@
                         </a:defRPr>
                       </a:pPr>
                       <a:r>
-                        <a:t>CCC</a:t>
+                        <a:t>CCC (87%)</a:t>
                       </a:r>
                     </a:p>
                   </a:txBody>
@@ -10202,7 +10625,7 @@
               </a:defRPr>
             </a:pPr>
             <a:r>
-              <a:t>For strong credits (BB+/BB−), the premium is small (±60bp) and model-dependent. For stressed credits (CCC), it exceeds +260bp and is robust across models.</a:t>
+              <a:t>For strong credits (BB+/BB−, 2.0× coverage), the premium is small (±60bp) and model-dependent. For stressed credits (CCC, 1.15× coverage), it exceeds +260bp and is robust across models.</a:t>
             </a:r>
           </a:p>
         </p:txBody>
@@ -10414,7 +10837,7 @@
               </a:defRPr>
             </a:pPr>
             <a:r>
-              <a:t>Above ~400bp market spread, structural modelling is essential</a:t>
+              <a:t>Above ~75% LTV (~400bp spread), structural modelling is essential</a:t>
             </a:r>
           </a:p>
         </p:txBody>
@@ -10557,17 +10980,6 @@
                         <a:t>Low Impact</a:t>
                       </a:r>
                     </a:p>
-                  </a:txBody>
-                  <a:tcPr>
-                    <a:solidFill>
-                      <a:srgbClr val="4EC9B0"/>
-                    </a:solidFill>
-                  </a:tcPr>
-                </a:tc>
-                <a:tc>
-                  <a:txBody>
-                    <a:bodyPr/>
-                    <a:lstStyle/>
                     <a:p>
                       <a:pPr algn="ctr">
                         <a:defRPr sz="1000" b="1">
@@ -10578,7 +10990,7 @@
                         </a:defRPr>
                       </a:pPr>
                       <a:r>
-                        <a:t>Crossover</a:t>
+                        <a:t>(LTV &lt; 65%)</a:t>
                       </a:r>
                     </a:p>
                   </a:txBody>
@@ -10602,7 +11014,57 @@
                         </a:defRPr>
                       </a:pPr>
                       <a:r>
+                        <a:t>Crossover</a:t>
+                      </a:r>
+                    </a:p>
+                    <a:p>
+                      <a:pPr algn="ctr">
+                        <a:defRPr sz="1000" b="1">
+                          <a:solidFill>
+                            <a:srgbClr val="FFFFFF"/>
+                          </a:solidFill>
+                          <a:latin typeface="Calibri"/>
+                        </a:defRPr>
+                      </a:pPr>
+                      <a:r>
+                        <a:t>(LTV 65–75%)</a:t>
+                      </a:r>
+                    </a:p>
+                  </a:txBody>
+                  <a:tcPr>
+                    <a:solidFill>
+                      <a:srgbClr val="4EC9B0"/>
+                    </a:solidFill>
+                  </a:tcPr>
+                </a:tc>
+                <a:tc>
+                  <a:txBody>
+                    <a:bodyPr/>
+                    <a:lstStyle/>
+                    <a:p>
+                      <a:pPr algn="ctr">
+                        <a:defRPr sz="1000" b="1">
+                          <a:solidFill>
+                            <a:srgbClr val="FFFFFF"/>
+                          </a:solidFill>
+                          <a:latin typeface="Calibri"/>
+                        </a:defRPr>
+                      </a:pPr>
+                      <a:r>
                         <a:t>Structural Risk</a:t>
+                      </a:r>
+                    </a:p>
+                    <a:p>
+                      <a:pPr algn="ctr">
+                        <a:defRPr sz="1000" b="1">
+                          <a:solidFill>
+                            <a:srgbClr val="FFFFFF"/>
+                          </a:solidFill>
+                          <a:latin typeface="Calibri"/>
+                        </a:defRPr>
+                      </a:pPr>
+                      <a:r>
+                        <a:t>(LTV &gt; 75%)</a:t>
                       </a:r>
                     </a:p>
                   </a:txBody>

</xml_diff>